<commit_message>
Met a jour le PPT : 113 tests (etait 97), 3 roles applicatifs (etait 2)
</commit_message>
<xml_diff>
--- a/08-soutenance/soutenance-scoolize-condensee.pptx
+++ b/08-soutenance/soutenance-scoolize-condensee.pptx
@@ -10896,7 +10896,7 @@
             <a:avLst/>
           </a:prstGeom>
           <a:solidFill>
-            <a:srgbClr val="DC2626"/>
+            <a:srgbClr val="0369A1"/>
           </a:solidFill>
           <a:ln>
             <a:noFill/>
@@ -10955,11 +10955,11 @@
             <a:r>
               <a:rPr sz="1300" b="1" i="0">
                 <a:solidFill>
-                  <a:srgbClr val="DC2626"/>
-                </a:solidFill>
-                <a:latin typeface="Source Sans 3"/>
-              </a:rPr>
-              <a:t>UN ENGAGEMENT FORT</a:t>
+                  <a:srgbClr val="0369A1"/>
+                </a:solidFill>
+                <a:latin typeface="Source Sans 3"/>
+              </a:rPr>
+              <a:t>EXPLICATIONS TECHNIQUES</a:t>
             </a:r>
           </a:p>
         </p:txBody>
@@ -10998,7 +10998,7 @@
                 </a:solidFill>
                 <a:latin typeface="Lexend"/>
               </a:rPr>
-              <a:t>Protéger les données, rester juste envers tous</a:t>
+              <a:t>La stack backend, en détail</a:t>
             </a:r>
           </a:p>
         </p:txBody>
@@ -11036,20 +11036,29 @@
             <a:r>
               <a:rPr sz="1800" b="1">
                 <a:solidFill>
-                  <a:srgbClr val="DC2626"/>
+                  <a:srgbClr val="0369A1"/>
                 </a:solidFill>
                 <a:latin typeface="Source Sans 3"/>
               </a:rPr>
               <a:t>▸  </a:t>
             </a:r>
             <a:r>
+              <a:rPr sz="1800" b="1">
+                <a:solidFill>
+                  <a:srgbClr val="0F172A"/>
+                </a:solidFill>
+                <a:latin typeface="Source Sans 3"/>
+              </a:rPr>
+              <a:t>Node.js + Express — </a:t>
+            </a:r>
+            <a:r>
               <a:rPr sz="1800">
                 <a:solidFill>
                   <a:srgbClr val="334155"/>
                 </a:solidFill>
                 <a:latin typeface="Source Sans 3"/>
               </a:rPr>
-              <a:t>Les informations des élèves ne sont jamais utilisées à leur désavantage.</a:t>
+              <a:t>moteur de l'API REST. Même langage que le frontend (JavaScript partout), simple à prendre en main en équipe.</a:t>
             </a:r>
           </a:p>
           <a:p>
@@ -11064,7 +11073,7 @@
             <a:r>
               <a:rPr sz="1800" b="1">
                 <a:solidFill>
-                  <a:srgbClr val="DC2626"/>
+                  <a:srgbClr val="0369A1"/>
                 </a:solidFill>
                 <a:latin typeface="Source Sans 3"/>
               </a:rPr>
@@ -11077,7 +11086,7 @@
                 </a:solidFill>
                 <a:latin typeface="Source Sans 3"/>
               </a:rPr>
-              <a:t>Le score n'est jamais la décision finale — </a:t>
+              <a:t>PostgreSQL + Prisma — </a:t>
             </a:r>
             <a:r>
               <a:rPr sz="1800">
@@ -11086,7 +11095,7 @@
                 </a:solidFill>
                 <a:latin typeface="Source Sans 3"/>
               </a:rPr>
-              <a:t>la décision reste toujours prise par des personnes.</a:t>
+              <a:t>base de données relationnelle réelle (5 tables liées), migrations versionnées, requêtes sécurisées sans SQL manuel.</a:t>
             </a:r>
           </a:p>
           <a:p>
@@ -11101,20 +11110,66 @@
             <a:r>
               <a:rPr sz="1800" b="1">
                 <a:solidFill>
-                  <a:srgbClr val="DC2626"/>
+                  <a:srgbClr val="0369A1"/>
                 </a:solidFill>
                 <a:latin typeface="Source Sans 3"/>
               </a:rPr>
               <a:t>▸  </a:t>
             </a:r>
             <a:r>
+              <a:rPr sz="1800" b="1">
+                <a:solidFill>
+                  <a:srgbClr val="0F172A"/>
+                </a:solidFill>
+                <a:latin typeface="Source Sans 3"/>
+              </a:rPr>
+              <a:t>JWT + bcrypt — </a:t>
+            </a:r>
+            <a:r>
               <a:rPr sz="1800">
                 <a:solidFill>
                   <a:srgbClr val="334155"/>
                 </a:solidFill>
                 <a:latin typeface="Source Sans 3"/>
               </a:rPr>
-              <a:t>Chaque élève garde le contrôle sur ses propres données, à tout moment.</a:t>
+              <a:t>mot de passe haché, jamais stocké en clair. Session représentée par un jeton signé, vérifié à chaque requête protégée.</a:t>
+            </a:r>
+          </a:p>
+          <a:p>
+            <a:pPr algn="l">
+              <a:lnSpc>
+                <a:spcPct val="130000"/>
+              </a:lnSpc>
+              <a:spcAft>
+                <a:spcPts val="900"/>
+              </a:spcAft>
+            </a:pPr>
+            <a:r>
+              <a:rPr sz="1800" b="1">
+                <a:solidFill>
+                  <a:srgbClr val="0369A1"/>
+                </a:solidFill>
+                <a:latin typeface="Source Sans 3"/>
+              </a:rPr>
+              <a:t>▸  </a:t>
+            </a:r>
+            <a:r>
+              <a:rPr sz="1800" b="1">
+                <a:solidFill>
+                  <a:srgbClr val="0F172A"/>
+                </a:solidFill>
+                <a:latin typeface="Source Sans 3"/>
+              </a:rPr>
+              <a:t>Zod — </a:t>
+            </a:r>
+            <a:r>
+              <a:rPr sz="1800">
+                <a:solidFill>
+                  <a:srgbClr val="334155"/>
+                </a:solidFill>
+                <a:latin typeface="Source Sans 3"/>
+              </a:rPr>
+              <a:t>validation de toutes les données entrantes (email, mot de passe, numéro INE) avec un message d'erreur clair par champ.</a:t>
             </a:r>
           </a:p>
         </p:txBody>
@@ -11232,11 +11287,11 @@
             <a:r>
               <a:rPr sz="900" b="1" i="0">
                 <a:solidFill>
-                  <a:srgbClr val="DC2626"/>
-                </a:solidFill>
-                <a:latin typeface="Source Sans 3"/>
-              </a:rPr>
-              <a:t>SYNTHÈSE</a:t>
+                  <a:srgbClr val="0369A1"/>
+                </a:solidFill>
+                <a:latin typeface="Source Sans 3"/>
+              </a:rPr>
+              <a:t>EXPLICATIONS TECHNIQUES</a:t>
             </a:r>
           </a:p>
         </p:txBody>
@@ -11275,7 +11330,7 @@
                 </a:solidFill>
                 <a:latin typeface="Source Sans 3"/>
               </a:rPr>
-              <a:t>22</a:t>
+              <a:t>18</a:t>
             </a:r>
           </a:p>
         </p:txBody>
@@ -11357,7 +11412,7 @@
             <a:avLst/>
           </a:prstGeom>
           <a:solidFill>
-            <a:srgbClr val="D97706"/>
+            <a:srgbClr val="0369A1"/>
           </a:solidFill>
           <a:ln>
             <a:noFill/>
@@ -11416,11 +11471,11 @@
             <a:r>
               <a:rPr sz="1300" b="1" i="0">
                 <a:solidFill>
-                  <a:srgbClr val="D97706"/>
-                </a:solidFill>
-                <a:latin typeface="Source Sans 3"/>
-              </a:rPr>
-              <a:t>AMÉLIORATIONS FUTURES</a:t>
+                  <a:srgbClr val="0369A1"/>
+                </a:solidFill>
+                <a:latin typeface="Source Sans 3"/>
+              </a:rPr>
+              <a:t>EXPLICATIONS TECHNIQUES</a:t>
             </a:r>
           </a:p>
         </p:txBody>
@@ -11459,7 +11514,7 @@
                 </a:solidFill>
                 <a:latin typeface="Lexend"/>
               </a:rPr>
-              <a:t>Les évolutions envisagées pour la suite</a:t>
+              <a:t>Frontend, tests, documentation et déploiement</a:t>
             </a:r>
           </a:p>
         </p:txBody>
@@ -11497,7 +11552,7 @@
             <a:r>
               <a:rPr sz="1800" b="1">
                 <a:solidFill>
-                  <a:srgbClr val="D97706"/>
+                  <a:srgbClr val="0369A1"/>
                 </a:solidFill>
                 <a:latin typeface="Source Sans 3"/>
               </a:rPr>
@@ -11510,7 +11565,7 @@
                 </a:solidFill>
                 <a:latin typeface="Source Sans 3"/>
               </a:rPr>
-              <a:t>Calcul réel du score de correspondance — </a:t>
+              <a:t>HTML / CSS / JS natif — </a:t>
             </a:r>
             <a:r>
               <a:rPr sz="1800">
@@ -11519,7 +11574,7 @@
                 </a:solidFill>
                 <a:latin typeface="Source Sans 3"/>
               </a:rPr>
-              <a:t>aujourd'hui illustratif sur la fiche formation, à remplacer par un algorithme s'appuyant sur le référentiel de compétences.</a:t>
+              <a:t>même design system que le prototype déjà validé, sans framework. Connecté à l'API réelle via fetch().</a:t>
             </a:r>
           </a:p>
           <a:p>
@@ -11534,7 +11589,7 @@
             <a:r>
               <a:rPr sz="1800" b="1">
                 <a:solidFill>
-                  <a:srgbClr val="D97706"/>
+                  <a:srgbClr val="0369A1"/>
                 </a:solidFill>
                 <a:latin typeface="Source Sans 3"/>
               </a:rPr>
@@ -11547,7 +11602,7 @@
                 </a:solidFill>
                 <a:latin typeface="Source Sans 3"/>
               </a:rPr>
-              <a:t>Brancher le référentiel Prepare sur l'API — </a:t>
+              <a:t>Jest + Supertest — </a:t>
             </a:r>
             <a:r>
               <a:rPr sz="1800">
@@ -11556,7 +11611,7 @@
                 </a:solidFill>
                 <a:latin typeface="Source Sans 3"/>
               </a:rPr>
-              <a:t>le constructeur de critères pondérés reste pour l'instant un mockup visuel non connecté à la base de données.</a:t>
+              <a:t>113 tests automatisés, exécutés contre une vraie base PostgreSQL de test — aucune fonctionnalité simulée.</a:t>
             </a:r>
           </a:p>
           <a:p>
@@ -11571,7 +11626,7 @@
             <a:r>
               <a:rPr sz="1800" b="1">
                 <a:solidFill>
-                  <a:srgbClr val="D97706"/>
+                  <a:srgbClr val="0369A1"/>
                 </a:solidFill>
                 <a:latin typeface="Source Sans 3"/>
               </a:rPr>
@@ -11584,7 +11639,7 @@
                 </a:solidFill>
                 <a:latin typeface="Source Sans 3"/>
               </a:rPr>
-              <a:t>Renforcer la sécurité de l'authentification — </a:t>
+              <a:t>Swagger / OpenAPI — </a:t>
             </a:r>
             <a:r>
               <a:rPr sz="1800">
@@ -11593,7 +11648,7 @@
                 </a:solidFill>
                 <a:latin typeface="Source Sans 3"/>
               </a:rPr>
-              <a:t>passer du jeton JWT en localStorage à un cookie httpOnly avec rafraîchissement automatique (refresh token).</a:t>
+              <a:t>documentation interactive de chaque route (/api/docs), générée directement depuis le code.</a:t>
             </a:r>
           </a:p>
           <a:p>
@@ -11608,7 +11663,7 @@
             <a:r>
               <a:rPr sz="1800" b="1">
                 <a:solidFill>
-                  <a:srgbClr val="D97706"/>
+                  <a:srgbClr val="0369A1"/>
                 </a:solidFill>
                 <a:latin typeface="Source Sans 3"/>
               </a:rPr>
@@ -11621,7 +11676,7 @@
                 </a:solidFill>
                 <a:latin typeface="Source Sans 3"/>
               </a:rPr>
-              <a:t>Intégration continue &amp; tests réels — </a:t>
+              <a:t>Docker Compose — </a:t>
             </a:r>
             <a:r>
               <a:rPr sz="1800">
@@ -11630,7 +11685,7 @@
                 </a:solidFill>
                 <a:latin typeface="Source Sans 3"/>
               </a:rPr>
-              <a:t>exécuter les 97 tests automatiquement à chaque modification, puis tester l'outil avec de vrais élèves et établissements.</a:t>
+              <a:t>3 conteneurs (base de données, API, frontend) lancés en une seule commande, sans installation manuelle.</a:t>
             </a:r>
           </a:p>
         </p:txBody>
@@ -11748,11 +11803,11 @@
             <a:r>
               <a:rPr sz="900" b="1" i="0">
                 <a:solidFill>
-                  <a:srgbClr val="D97706"/>
-                </a:solidFill>
-                <a:latin typeface="Source Sans 3"/>
-              </a:rPr>
-              <a:t>SYNTHÈSE</a:t>
+                  <a:srgbClr val="0369A1"/>
+                </a:solidFill>
+                <a:latin typeface="Source Sans 3"/>
+              </a:rPr>
+              <a:t>EXPLICATIONS TECHNIQUES</a:t>
             </a:r>
           </a:p>
         </p:txBody>
@@ -11791,7 +11846,7 @@
                 </a:solidFill>
                 <a:latin typeface="Source Sans 3"/>
               </a:rPr>
-              <a:t>24</a:t>
+              <a:t>19</a:t>
             </a:r>
           </a:p>
         </p:txBody>
@@ -12345,7 +12400,7 @@
             <a:avLst/>
           </a:prstGeom>
           <a:solidFill>
-            <a:srgbClr val="0F3D91"/>
+            <a:srgbClr val="F8FAFC"/>
           </a:solidFill>
           <a:ln>
             <a:noFill/>
@@ -12383,10 +12438,221 @@
         <p:spPr>
           <a:xfrm>
             <a:off x="0" y="0"/>
-            <a:ext cx="12191695" cy="6858000"/>
-          </a:xfrm>
-          <a:prstGeom prst="rect">
-            <a:avLst/>
+            <a:ext cx="12191695" cy="109728"/>
+          </a:xfrm>
+          <a:prstGeom prst="rect">
+            <a:avLst/>
+          </a:prstGeom>
+          <a:solidFill>
+            <a:srgbClr val="0369A1"/>
+          </a:solidFill>
+          <a:ln>
+            <a:noFill/>
+          </a:ln>
+          <a:effectLst/>
+        </p:spPr>
+        <p:style>
+          <a:lnRef idx="1">
+            <a:schemeClr val="accent1"/>
+          </a:lnRef>
+          <a:fillRef idx="3">
+            <a:schemeClr val="accent1"/>
+          </a:fillRef>
+          <a:effectRef idx="2">
+            <a:schemeClr val="accent1"/>
+          </a:effectRef>
+          <a:fontRef idx="minor">
+            <a:schemeClr val="lt1"/>
+          </a:fontRef>
+        </p:style>
+        <p:txBody>
+          <a:bodyPr rtlCol="0" anchor="ctr"/>
+          <a:lstStyle/>
+          <a:p>
+            <a:pPr algn="ctr"/>
+          </a:p>
+        </p:txBody>
+      </p:sp>
+      <p:sp>
+        <p:nvSpPr>
+          <p:cNvPr id="4" name="TextBox 3"/>
+          <p:cNvSpPr txBox="1"/>
+          <p:nvPr/>
+        </p:nvSpPr>
+        <p:spPr>
+          <a:xfrm>
+            <a:off x="640080" y="384048"/>
+            <a:ext cx="9144000" cy="320040"/>
+          </a:xfrm>
+          <a:prstGeom prst="rect">
+            <a:avLst/>
+          </a:prstGeom>
+          <a:noFill/>
+        </p:spPr>
+        <p:txBody>
+          <a:bodyPr wrap="square" anchor="t" lIns="0" rIns="0" tIns="0" bIns="0">
+            <a:spAutoFit/>
+          </a:bodyPr>
+          <a:lstStyle/>
+          <a:p>
+            <a:pPr algn="l">
+              <a:lnSpc>
+                <a:spcPct val="115000"/>
+              </a:lnSpc>
+            </a:pPr>
+            <a:r>
+              <a:rPr sz="1300" b="1" i="0">
+                <a:solidFill>
+                  <a:srgbClr val="0369A1"/>
+                </a:solidFill>
+                <a:latin typeface="Source Sans 3"/>
+              </a:rPr>
+              <a:t>EXPLICATIONS TECHNIQUES</a:t>
+            </a:r>
+          </a:p>
+        </p:txBody>
+      </p:sp>
+      <p:sp>
+        <p:nvSpPr>
+          <p:cNvPr id="5" name="TextBox 4"/>
+          <p:cNvSpPr txBox="1"/>
+          <p:nvPr/>
+        </p:nvSpPr>
+        <p:spPr>
+          <a:xfrm>
+            <a:off x="640080" y="685800"/>
+            <a:ext cx="10881360" cy="822960"/>
+          </a:xfrm>
+          <a:prstGeom prst="rect">
+            <a:avLst/>
+          </a:prstGeom>
+          <a:noFill/>
+        </p:spPr>
+        <p:txBody>
+          <a:bodyPr wrap="square" anchor="t" lIns="0" rIns="0" tIns="0" bIns="0">
+            <a:spAutoFit/>
+          </a:bodyPr>
+          <a:lstStyle/>
+          <a:p>
+            <a:pPr algn="l">
+              <a:lnSpc>
+                <a:spcPct val="105000"/>
+              </a:lnSpc>
+            </a:pPr>
+            <a:r>
+              <a:rPr sz="3000" b="1" i="0">
+                <a:solidFill>
+                  <a:srgbClr val="0F172A"/>
+                </a:solidFill>
+                <a:latin typeface="Lexend"/>
+              </a:rPr>
+              <a:t>Architecture générale de l'application</a:t>
+            </a:r>
+          </a:p>
+        </p:txBody>
+      </p:sp>
+      <p:sp>
+        <p:nvSpPr>
+          <p:cNvPr id="6" name="Rounded Rectangle 5"/>
+          <p:cNvSpPr/>
+          <p:nvPr/>
+        </p:nvSpPr>
+        <p:spPr>
+          <a:xfrm>
+            <a:off x="640080" y="1828800"/>
+            <a:ext cx="10881360" cy="777240"/>
+          </a:xfrm>
+          <a:prstGeom prst="roundRect">
+            <a:avLst>
+              <a:gd name="adj" fmla="val 10000"/>
+            </a:avLst>
+          </a:prstGeom>
+          <a:solidFill>
+            <a:srgbClr val="FFFFFF"/>
+          </a:solidFill>
+          <a:ln w="12700">
+            <a:solidFill>
+              <a:srgbClr val="E2E8F0"/>
+            </a:solidFill>
+          </a:ln>
+          <a:effectLst/>
+        </p:spPr>
+        <p:style>
+          <a:lnRef idx="1">
+            <a:schemeClr val="accent1"/>
+          </a:lnRef>
+          <a:fillRef idx="3">
+            <a:schemeClr val="accent1"/>
+          </a:fillRef>
+          <a:effectRef idx="2">
+            <a:schemeClr val="accent1"/>
+          </a:effectRef>
+          <a:fontRef idx="minor">
+            <a:schemeClr val="lt1"/>
+          </a:fontRef>
+        </p:style>
+        <p:txBody>
+          <a:bodyPr rtlCol="0" anchor="ctr"/>
+          <a:lstStyle/>
+          <a:p>
+            <a:pPr algn="ctr"/>
+          </a:p>
+        </p:txBody>
+      </p:sp>
+      <p:sp>
+        <p:nvSpPr>
+          <p:cNvPr id="7" name="TextBox 6"/>
+          <p:cNvSpPr txBox="1"/>
+          <p:nvPr/>
+        </p:nvSpPr>
+        <p:spPr>
+          <a:xfrm>
+            <a:off x="914400" y="1993392"/>
+            <a:ext cx="10332720" cy="457200"/>
+          </a:xfrm>
+          <a:prstGeom prst="rect">
+            <a:avLst/>
+          </a:prstGeom>
+          <a:noFill/>
+        </p:spPr>
+        <p:txBody>
+          <a:bodyPr wrap="square" anchor="ctr" lIns="0" rIns="0" tIns="0" bIns="0">
+            <a:spAutoFit/>
+          </a:bodyPr>
+          <a:lstStyle/>
+          <a:p>
+            <a:pPr algn="ctr">
+              <a:lnSpc>
+                <a:spcPct val="115000"/>
+              </a:lnSpc>
+            </a:pPr>
+            <a:r>
+              <a:rPr sz="1400" b="1" i="0">
+                <a:solidFill>
+                  <a:srgbClr val="334155"/>
+                </a:solidFill>
+                <a:latin typeface="Source Sans 3"/>
+              </a:rPr>
+              <a:t>NAVIGATEUR — frontend HTML / CSS / JS statique</a:t>
+            </a:r>
+          </a:p>
+        </p:txBody>
+      </p:sp>
+      <p:sp>
+        <p:nvSpPr>
+          <p:cNvPr id="8" name="Rounded Rectangle 7"/>
+          <p:cNvSpPr/>
+          <p:nvPr/>
+        </p:nvSpPr>
+        <p:spPr>
+          <a:xfrm>
+            <a:off x="2926080" y="3200400"/>
+            <a:ext cx="2377440" cy="640080"/>
+          </a:xfrm>
+          <a:prstGeom prst="roundRect">
+            <a:avLst>
+              <a:gd name="adj" fmla="val 15000"/>
+            </a:avLst>
           </a:prstGeom>
           <a:solidFill>
             <a:srgbClr val="0F3D91"/>
@@ -12420,20 +12686,61 @@
       </p:sp>
       <p:sp>
         <p:nvSpPr>
-          <p:cNvPr id="4" name="Rectangle 3"/>
+          <p:cNvPr id="9" name="TextBox 8"/>
+          <p:cNvSpPr txBox="1"/>
+          <p:nvPr/>
+        </p:nvSpPr>
+        <p:spPr>
+          <a:xfrm>
+            <a:off x="2926080" y="3355848"/>
+            <a:ext cx="2377440" cy="365760"/>
+          </a:xfrm>
+          <a:prstGeom prst="rect">
+            <a:avLst/>
+          </a:prstGeom>
+          <a:noFill/>
+        </p:spPr>
+        <p:txBody>
+          <a:bodyPr wrap="square" anchor="t" lIns="0" rIns="0" tIns="0" bIns="0">
+            <a:spAutoFit/>
+          </a:bodyPr>
+          <a:lstStyle/>
+          <a:p>
+            <a:pPr algn="ctr">
+              <a:lnSpc>
+                <a:spcPct val="115000"/>
+              </a:lnSpc>
+            </a:pPr>
+            <a:r>
+              <a:rPr sz="1500" b="1" i="0">
+                <a:solidFill>
+                  <a:srgbClr val="FFFFFF"/>
+                </a:solidFill>
+                <a:latin typeface="Source Sans 3"/>
+              </a:rPr>
+              <a:t>API REST</a:t>
+            </a:r>
+          </a:p>
+        </p:txBody>
+      </p:sp>
+      <p:sp>
+        <p:nvSpPr>
+          <p:cNvPr id="10" name="Rounded Rectangle 9"/>
           <p:cNvSpPr/>
           <p:nvPr/>
         </p:nvSpPr>
         <p:spPr>
           <a:xfrm>
-            <a:off x="0" y="0"/>
-            <a:ext cx="12191695" cy="146304"/>
-          </a:xfrm>
-          <a:prstGeom prst="rect">
-            <a:avLst/>
+            <a:off x="6903720" y="3200400"/>
+            <a:ext cx="2377440" cy="640080"/>
+          </a:xfrm>
+          <a:prstGeom prst="roundRect">
+            <a:avLst>
+              <a:gd name="adj" fmla="val 15000"/>
+            </a:avLst>
           </a:prstGeom>
           <a:solidFill>
-            <a:srgbClr val="F59E0B"/>
+            <a:srgbClr val="0D9488"/>
           </a:solidFill>
           <a:ln>
             <a:noFill/>
@@ -12464,14 +12771,14 @@
       </p:sp>
       <p:sp>
         <p:nvSpPr>
-          <p:cNvPr id="5" name="TextBox 4"/>
+          <p:cNvPr id="11" name="TextBox 10"/>
           <p:cNvSpPr txBox="1"/>
           <p:nvPr/>
         </p:nvSpPr>
         <p:spPr>
           <a:xfrm>
-            <a:off x="822960" y="2286000"/>
-            <a:ext cx="10515600" cy="1097280"/>
+            <a:off x="6903720" y="3355848"/>
+            <a:ext cx="2377440" cy="365760"/>
           </a:xfrm>
           <a:prstGeom prst="rect">
             <a:avLst/>
@@ -12484,33 +12791,79 @@
           </a:bodyPr>
           <a:lstStyle/>
           <a:p>
-            <a:pPr algn="l">
+            <a:pPr algn="ctr">
               <a:lnSpc>
                 <a:spcPct val="115000"/>
               </a:lnSpc>
             </a:pPr>
             <a:r>
-              <a:rPr sz="6000" b="1" i="0">
+              <a:rPr sz="1500" b="1" i="0">
                 <a:solidFill>
                   <a:srgbClr val="FFFFFF"/>
                 </a:solidFill>
-                <a:latin typeface="Lexend"/>
-              </a:rPr>
-              <a:t>Merci.</a:t>
-            </a:r>
-          </a:p>
-        </p:txBody>
-      </p:sp>
-      <p:sp>
-        <p:nvSpPr>
-          <p:cNvPr id="6" name="TextBox 5"/>
+                <a:latin typeface="Source Sans 3"/>
+              </a:rPr>
+              <a:t>SWAGGER</a:t>
+            </a:r>
+          </a:p>
+        </p:txBody>
+      </p:sp>
+      <p:sp>
+        <p:nvSpPr>
+          <p:cNvPr id="12" name="Rounded Rectangle 11"/>
+          <p:cNvSpPr/>
+          <p:nvPr/>
+        </p:nvSpPr>
+        <p:spPr>
+          <a:xfrm>
+            <a:off x="3246120" y="4343400"/>
+            <a:ext cx="5669280" cy="777240"/>
+          </a:xfrm>
+          <a:prstGeom prst="roundRect">
+            <a:avLst>
+              <a:gd name="adj" fmla="val 12000"/>
+            </a:avLst>
+          </a:prstGeom>
+          <a:solidFill>
+            <a:srgbClr val="0369A1"/>
+          </a:solidFill>
+          <a:ln>
+            <a:noFill/>
+          </a:ln>
+          <a:effectLst/>
+        </p:spPr>
+        <p:style>
+          <a:lnRef idx="1">
+            <a:schemeClr val="accent1"/>
+          </a:lnRef>
+          <a:fillRef idx="3">
+            <a:schemeClr val="accent1"/>
+          </a:fillRef>
+          <a:effectRef idx="2">
+            <a:schemeClr val="accent1"/>
+          </a:effectRef>
+          <a:fontRef idx="minor">
+            <a:schemeClr val="lt1"/>
+          </a:fontRef>
+        </p:style>
+        <p:txBody>
+          <a:bodyPr rtlCol="0" anchor="ctr"/>
+          <a:lstStyle/>
+          <a:p>
+            <a:pPr algn="ctr"/>
+          </a:p>
+        </p:txBody>
+      </p:sp>
+      <p:sp>
+        <p:nvSpPr>
+          <p:cNvPr id="13" name="TextBox 12"/>
           <p:cNvSpPr txBox="1"/>
           <p:nvPr/>
         </p:nvSpPr>
         <p:spPr>
           <a:xfrm>
-            <a:off x="822960" y="3474720"/>
-            <a:ext cx="10058400" cy="914400"/>
+            <a:off x="3429000" y="4480560"/>
+            <a:ext cx="5303520" cy="548640"/>
           </a:xfrm>
           <a:prstGeom prst="rect">
             <a:avLst/>
@@ -12523,49 +12876,49 @@
           </a:bodyPr>
           <a:lstStyle/>
           <a:p>
-            <a:pPr algn="l">
-              <a:lnSpc>
-                <a:spcPct val="130000"/>
-              </a:lnSpc>
-            </a:pPr>
-            <a:r>
-              <a:rPr sz="2000" b="0" i="0">
-                <a:solidFill>
-                  <a:srgbClr val="D8F2EE"/>
-                </a:solidFill>
-                <a:latin typeface="Source Sans 3"/>
-              </a:rPr>
-              <a:t>Scoolize aide chaque élève à comprendre ses chances,</a:t>
-            </a:r>
-          </a:p>
-          <a:p>
-            <a:pPr algn="l">
-              <a:lnSpc>
-                <a:spcPct val="130000"/>
-              </a:lnSpc>
-            </a:pPr>
-            <a:r>
-              <a:rPr sz="2000" b="0" i="0">
-                <a:solidFill>
-                  <a:srgbClr val="D8F2EE"/>
-                </a:solidFill>
-                <a:latin typeface="Source Sans 3"/>
-              </a:rPr>
-              <a:t>et chaque établissement à expliquer ses attentes.</a:t>
-            </a:r>
-          </a:p>
-        </p:txBody>
-      </p:sp>
-      <p:sp>
-        <p:nvSpPr>
-          <p:cNvPr id="7" name="TextBox 6"/>
+            <a:pPr algn="ctr">
+              <a:lnSpc>
+                <a:spcPct val="110000"/>
+              </a:lnSpc>
+            </a:pPr>
+            <a:r>
+              <a:rPr sz="1350" b="1" i="0">
+                <a:solidFill>
+                  <a:srgbClr val="FFFFFF"/>
+                </a:solidFill>
+                <a:latin typeface="Source Sans 3"/>
+              </a:rPr>
+              <a:t>BASE DE DONNÉES POSTGRESQL</a:t>
+            </a:r>
+          </a:p>
+          <a:p>
+            <a:pPr algn="ctr">
+              <a:lnSpc>
+                <a:spcPct val="110000"/>
+              </a:lnSpc>
+            </a:pPr>
+            <a:r>
+              <a:rPr sz="1350" b="1" i="0">
+                <a:solidFill>
+                  <a:srgbClr val="FFFFFF"/>
+                </a:solidFill>
+                <a:latin typeface="Source Sans 3"/>
+              </a:rPr>
+              <a:t>5 tables reliées, via Prisma ORM</a:t>
+            </a:r>
+          </a:p>
+        </p:txBody>
+      </p:sp>
+      <p:sp>
+        <p:nvSpPr>
+          <p:cNvPr id="14" name="TextBox 13"/>
           <p:cNvSpPr txBox="1"/>
           <p:nvPr/>
         </p:nvSpPr>
         <p:spPr>
           <a:xfrm>
-            <a:off x="822960" y="6035040"/>
-            <a:ext cx="9144000" cy="365760"/>
+            <a:off x="640080" y="5486400"/>
+            <a:ext cx="10881360" cy="731520"/>
           </a:xfrm>
           <a:prstGeom prst="rect">
             <a:avLst/>
@@ -12578,26 +12931,26 @@
           </a:bodyPr>
           <a:lstStyle/>
           <a:p>
-            <a:pPr algn="l">
+            <a:pPr algn="ctr">
               <a:lnSpc>
                 <a:spcPct val="115000"/>
               </a:lnSpc>
             </a:pPr>
             <a:r>
-              <a:rPr sz="1200" b="0" i="0">
-                <a:solidFill>
-                  <a:srgbClr val="DCE6F7"/>
-                </a:solidFill>
-                <a:latin typeface="Source Sans 3"/>
-              </a:rPr>
-              <a:t>EPI'Gency Digital — Scoolize — Prepare &amp; Predict</a:t>
-            </a:r>
-          </a:p>
-        </p:txBody>
-      </p:sp>
-      <p:sp>
-        <p:nvSpPr>
-          <p:cNvPr id="8" name="Rectangle 7"/>
+              <a:rPr sz="1350" b="0" i="1">
+                <a:solidFill>
+                  <a:srgbClr val="64748B"/>
+                </a:solidFill>
+                <a:latin typeface="Source Sans 3"/>
+              </a:rPr>
+              <a:t>Le frontend appelle l'API en JSON (fetch + jeton JWT). L'API valide les données (Zod) puis lit/écrit dans PostgreSQL via Prisma — jamais d'accès direct du frontend à la base.</a:t>
+            </a:r>
+          </a:p>
+        </p:txBody>
+      </p:sp>
+      <p:sp>
+        <p:nvSpPr>
+          <p:cNvPr id="15" name="Rectangle 14"/>
           <p:cNvSpPr/>
           <p:nvPr/>
         </p:nvSpPr>
@@ -12641,7 +12994,7 @@
       </p:sp>
       <p:sp>
         <p:nvSpPr>
-          <p:cNvPr id="9" name="TextBox 8"/>
+          <p:cNvPr id="16" name="TextBox 15"/>
           <p:cNvSpPr txBox="1"/>
           <p:nvPr/>
         </p:nvSpPr>
@@ -12680,7 +13033,7 @@
       </p:sp>
       <p:sp>
         <p:nvSpPr>
-          <p:cNvPr id="10" name="TextBox 9"/>
+          <p:cNvPr id="17" name="TextBox 16"/>
           <p:cNvSpPr txBox="1"/>
           <p:nvPr/>
         </p:nvSpPr>
@@ -12708,18 +13061,18 @@
             <a:r>
               <a:rPr sz="900" b="1" i="0">
                 <a:solidFill>
-                  <a:srgbClr val="E2E8F0"/>
-                </a:solidFill>
-                <a:latin typeface="Source Sans 3"/>
-              </a:rPr>
-              <a:t>MERCI</a:t>
-            </a:r>
-          </a:p>
-        </p:txBody>
-      </p:sp>
-      <p:sp>
-        <p:nvSpPr>
-          <p:cNvPr id="11" name="TextBox 10"/>
+                  <a:srgbClr val="0369A1"/>
+                </a:solidFill>
+                <a:latin typeface="Source Sans 3"/>
+              </a:rPr>
+              <a:t>EXPLICATIONS TECHNIQUES</a:t>
+            </a:r>
+          </a:p>
+        </p:txBody>
+      </p:sp>
+      <p:sp>
+        <p:nvSpPr>
+          <p:cNvPr id="18" name="TextBox 17"/>
           <p:cNvSpPr txBox="1"/>
           <p:nvPr/>
         </p:nvSpPr>
@@ -12751,7 +13104,7 @@
                 </a:solidFill>
                 <a:latin typeface="Source Sans 3"/>
               </a:rPr>
-              <a:t>25</a:t>
+              <a:t>20</a:t>
             </a:r>
           </a:p>
         </p:txBody>
@@ -12935,7 +13288,7 @@
                 </a:solidFill>
                 <a:latin typeface="Lexend"/>
               </a:rPr>
-              <a:t>La stack backend, en détail</a:t>
+              <a:t>API, base de données, rôles et gestion des erreurs</a:t>
             </a:r>
           </a:p>
         </p:txBody>
@@ -12986,7 +13339,7 @@
                 </a:solidFill>
                 <a:latin typeface="Source Sans 3"/>
               </a:rPr>
-              <a:t>Node.js + Express — </a:t>
+              <a:t>API REST par domaine — </a:t>
             </a:r>
             <a:r>
               <a:rPr sz="1800">
@@ -12995,7 +13348,7 @@
                 </a:solidFill>
                 <a:latin typeface="Source Sans 3"/>
               </a:rPr>
-              <a:t>moteur de l'API REST. Même langage que le frontend (JavaScript partout), simple à prendre en main en équipe.</a:t>
+              <a:t>un module par ressource (écoles, formations, statistiques, vœux, admin), avec routes, contrôleur, service et validation.</a:t>
             </a:r>
           </a:p>
           <a:p>
@@ -13023,7 +13376,7 @@
                 </a:solidFill>
                 <a:latin typeface="Source Sans 3"/>
               </a:rPr>
-              <a:t>PostgreSQL + Prisma — </a:t>
+              <a:t>Base de données relationnelle — </a:t>
             </a:r>
             <a:r>
               <a:rPr sz="1800">
@@ -13032,7 +13385,7 @@
                 </a:solidFill>
                 <a:latin typeface="Source Sans 3"/>
               </a:rPr>
-              <a:t>base de données relationnelle réelle (5 tables liées), migrations versionnées, requêtes sécurisées sans SQL manuel.</a:t>
+              <a:t>écoles → formations → statistiques ; étudiants → vœux → formations, reliées par des clés étrangères.</a:t>
             </a:r>
           </a:p>
           <a:p>
@@ -13060,7 +13413,7 @@
                 </a:solidFill>
                 <a:latin typeface="Source Sans 3"/>
               </a:rPr>
-              <a:t>JWT + bcrypt — </a:t>
+              <a:t>Trois rôles applicatifs — </a:t>
             </a:r>
             <a:r>
               <a:rPr sz="1800">
@@ -13069,7 +13422,7 @@
                 </a:solidFill>
                 <a:latin typeface="Source Sans 3"/>
               </a:rPr>
-              <a:t>mot de passe haché, jamais stocké en clair. Session représentée par un jeton signé, vérifié à chaque requête protégée.</a:t>
+              <a:t>ÉTUDIANT, PERSONNEL D'ÉTABLISSEMENT et ADMINISTRATEUR ; un personnel d'établissement ne gère que les formations de sa propre école (vérifié à chaque requête, pas seulement affiché).</a:t>
             </a:r>
           </a:p>
           <a:p>
@@ -13097,7 +13450,7 @@
                 </a:solidFill>
                 <a:latin typeface="Source Sans 3"/>
               </a:rPr>
-              <a:t>Zod — </a:t>
+              <a:t>Erreurs &amp; sécurité — </a:t>
             </a:r>
             <a:r>
               <a:rPr sz="1800">
@@ -13106,7 +13459,7 @@
                 </a:solidFill>
                 <a:latin typeface="Source Sans 3"/>
               </a:rPr>
-              <a:t>validation de toutes les données entrantes (email, mot de passe, numéro INE) avec un message d'erreur clair par champ.</a:t>
+              <a:t>messages clairs par champ, mots de passe hachés, jetons signés, CORS restreint à l'origine du frontend.</a:t>
             </a:r>
           </a:p>
         </p:txBody>
@@ -13267,7 +13620,7 @@
                 </a:solidFill>
                 <a:latin typeface="Source Sans 3"/>
               </a:rPr>
-              <a:t>18</a:t>
+              <a:t>21</a:t>
             </a:r>
           </a:p>
         </p:txBody>
@@ -13349,7 +13702,7 @@
             <a:avLst/>
           </a:prstGeom>
           <a:solidFill>
-            <a:srgbClr val="0369A1"/>
+            <a:srgbClr val="DC2626"/>
           </a:solidFill>
           <a:ln>
             <a:noFill/>
@@ -13408,11 +13761,11 @@
             <a:r>
               <a:rPr sz="1300" b="1" i="0">
                 <a:solidFill>
-                  <a:srgbClr val="0369A1"/>
-                </a:solidFill>
-                <a:latin typeface="Source Sans 3"/>
-              </a:rPr>
-              <a:t>EXPLICATIONS TECHNIQUES</a:t>
+                  <a:srgbClr val="DC2626"/>
+                </a:solidFill>
+                <a:latin typeface="Source Sans 3"/>
+              </a:rPr>
+              <a:t>UN ENGAGEMENT FORT</a:t>
             </a:r>
           </a:p>
         </p:txBody>
@@ -13451,7 +13804,7 @@
                 </a:solidFill>
                 <a:latin typeface="Lexend"/>
               </a:rPr>
-              <a:t>Frontend, tests, documentation et déploiement</a:t>
+              <a:t>Protéger les données, rester juste envers tous</a:t>
             </a:r>
           </a:p>
         </p:txBody>
@@ -13489,29 +13842,20 @@
             <a:r>
               <a:rPr sz="1800" b="1">
                 <a:solidFill>
-                  <a:srgbClr val="0369A1"/>
+                  <a:srgbClr val="DC2626"/>
                 </a:solidFill>
                 <a:latin typeface="Source Sans 3"/>
               </a:rPr>
               <a:t>▸  </a:t>
             </a:r>
             <a:r>
-              <a:rPr sz="1800" b="1">
-                <a:solidFill>
-                  <a:srgbClr val="0F172A"/>
-                </a:solidFill>
-                <a:latin typeface="Source Sans 3"/>
-              </a:rPr>
-              <a:t>HTML / CSS / JS natif — </a:t>
-            </a:r>
-            <a:r>
               <a:rPr sz="1800">
                 <a:solidFill>
                   <a:srgbClr val="334155"/>
                 </a:solidFill>
                 <a:latin typeface="Source Sans 3"/>
               </a:rPr>
-              <a:t>même design system que le prototype déjà validé, sans framework. Connecté à l'API réelle via fetch().</a:t>
+              <a:t>Les informations des élèves ne sont jamais utilisées à leur désavantage.</a:t>
             </a:r>
           </a:p>
           <a:p>
@@ -13526,7 +13870,7 @@
             <a:r>
               <a:rPr sz="1800" b="1">
                 <a:solidFill>
-                  <a:srgbClr val="0369A1"/>
+                  <a:srgbClr val="DC2626"/>
                 </a:solidFill>
                 <a:latin typeface="Source Sans 3"/>
               </a:rPr>
@@ -13539,7 +13883,7 @@
                 </a:solidFill>
                 <a:latin typeface="Source Sans 3"/>
               </a:rPr>
-              <a:t>Jest + Supertest — </a:t>
+              <a:t>Le score n'est jamais la décision finale — </a:t>
             </a:r>
             <a:r>
               <a:rPr sz="1800">
@@ -13548,7 +13892,7 @@
                 </a:solidFill>
                 <a:latin typeface="Source Sans 3"/>
               </a:rPr>
-              <a:t>97 tests automatisés, exécutés contre une vraie base PostgreSQL de test — aucune fonctionnalité simulée.</a:t>
+              <a:t>la décision reste toujours prise par des personnes.</a:t>
             </a:r>
           </a:p>
           <a:p>
@@ -13563,66 +13907,20 @@
             <a:r>
               <a:rPr sz="1800" b="1">
                 <a:solidFill>
-                  <a:srgbClr val="0369A1"/>
+                  <a:srgbClr val="DC2626"/>
                 </a:solidFill>
                 <a:latin typeface="Source Sans 3"/>
               </a:rPr>
               <a:t>▸  </a:t>
             </a:r>
             <a:r>
-              <a:rPr sz="1800" b="1">
-                <a:solidFill>
-                  <a:srgbClr val="0F172A"/>
-                </a:solidFill>
-                <a:latin typeface="Source Sans 3"/>
-              </a:rPr>
-              <a:t>Swagger / OpenAPI — </a:t>
-            </a:r>
-            <a:r>
               <a:rPr sz="1800">
                 <a:solidFill>
                   <a:srgbClr val="334155"/>
                 </a:solidFill>
                 <a:latin typeface="Source Sans 3"/>
               </a:rPr>
-              <a:t>documentation interactive de chaque route (/api/docs), générée directement depuis le code.</a:t>
-            </a:r>
-          </a:p>
-          <a:p>
-            <a:pPr algn="l">
-              <a:lnSpc>
-                <a:spcPct val="130000"/>
-              </a:lnSpc>
-              <a:spcAft>
-                <a:spcPts val="900"/>
-              </a:spcAft>
-            </a:pPr>
-            <a:r>
-              <a:rPr sz="1800" b="1">
-                <a:solidFill>
-                  <a:srgbClr val="0369A1"/>
-                </a:solidFill>
-                <a:latin typeface="Source Sans 3"/>
-              </a:rPr>
-              <a:t>▸  </a:t>
-            </a:r>
-            <a:r>
-              <a:rPr sz="1800" b="1">
-                <a:solidFill>
-                  <a:srgbClr val="0F172A"/>
-                </a:solidFill>
-                <a:latin typeface="Source Sans 3"/>
-              </a:rPr>
-              <a:t>Docker Compose — </a:t>
-            </a:r>
-            <a:r>
-              <a:rPr sz="1800">
-                <a:solidFill>
-                  <a:srgbClr val="334155"/>
-                </a:solidFill>
-                <a:latin typeface="Source Sans 3"/>
-              </a:rPr>
-              <a:t>3 conteneurs (base de données, API, frontend) lancés en une seule commande, sans installation manuelle.</a:t>
+              <a:t>Chaque élève garde le contrôle sur ses propres données, à tout moment.</a:t>
             </a:r>
           </a:p>
         </p:txBody>
@@ -13740,11 +14038,11 @@
             <a:r>
               <a:rPr sz="900" b="1" i="0">
                 <a:solidFill>
-                  <a:srgbClr val="0369A1"/>
-                </a:solidFill>
-                <a:latin typeface="Source Sans 3"/>
-              </a:rPr>
-              <a:t>EXPLICATIONS TECHNIQUES</a:t>
+                  <a:srgbClr val="DC2626"/>
+                </a:solidFill>
+                <a:latin typeface="Source Sans 3"/>
+              </a:rPr>
+              <a:t>SYNTHÈSE</a:t>
             </a:r>
           </a:p>
         </p:txBody>
@@ -13783,7 +14081,7 @@
                 </a:solidFill>
                 <a:latin typeface="Source Sans 3"/>
               </a:rPr>
-              <a:t>19</a:t>
+              <a:t>22</a:t>
             </a:r>
           </a:p>
         </p:txBody>
@@ -13865,7 +14163,7 @@
             <a:avLst/>
           </a:prstGeom>
           <a:solidFill>
-            <a:srgbClr val="0369A1"/>
+            <a:srgbClr val="D97706"/>
           </a:solidFill>
           <a:ln>
             <a:noFill/>
@@ -13924,11 +14222,11 @@
             <a:r>
               <a:rPr sz="1300" b="1" i="0">
                 <a:solidFill>
-                  <a:srgbClr val="0369A1"/>
-                </a:solidFill>
-                <a:latin typeface="Source Sans 3"/>
-              </a:rPr>
-              <a:t>EXPLICATIONS TECHNIQUES</a:t>
+                  <a:srgbClr val="D97706"/>
+                </a:solidFill>
+                <a:latin typeface="Source Sans 3"/>
+              </a:rPr>
+              <a:t>DIFFICULTÉS RENCONTRÉES</a:t>
             </a:r>
           </a:p>
         </p:txBody>
@@ -13967,69 +14265,21 @@
                 </a:solidFill>
                 <a:latin typeface="Lexend"/>
               </a:rPr>
-              <a:t>Architecture générale de l'application</a:t>
-            </a:r>
-          </a:p>
-        </p:txBody>
-      </p:sp>
-      <p:sp>
-        <p:nvSpPr>
-          <p:cNvPr id="6" name="Rounded Rectangle 5"/>
-          <p:cNvSpPr/>
-          <p:nvPr/>
-        </p:nvSpPr>
-        <p:spPr>
-          <a:xfrm>
-            <a:off x="640080" y="1828800"/>
-            <a:ext cx="10881360" cy="777240"/>
-          </a:xfrm>
-          <a:prstGeom prst="roundRect">
-            <a:avLst>
-              <a:gd name="adj" fmla="val 10000"/>
-            </a:avLst>
-          </a:prstGeom>
-          <a:solidFill>
-            <a:srgbClr val="FFFFFF"/>
-          </a:solidFill>
-          <a:ln w="12700">
-            <a:solidFill>
-              <a:srgbClr val="E2E8F0"/>
-            </a:solidFill>
-          </a:ln>
-          <a:effectLst/>
-        </p:spPr>
-        <p:style>
-          <a:lnRef idx="1">
-            <a:schemeClr val="accent1"/>
-          </a:lnRef>
-          <a:fillRef idx="3">
-            <a:schemeClr val="accent1"/>
-          </a:fillRef>
-          <a:effectRef idx="2">
-            <a:schemeClr val="accent1"/>
-          </a:effectRef>
-          <a:fontRef idx="minor">
-            <a:schemeClr val="lt1"/>
-          </a:fontRef>
-        </p:style>
-        <p:txBody>
-          <a:bodyPr rtlCol="0" anchor="ctr"/>
-          <a:lstStyle/>
-          <a:p>
-            <a:pPr algn="ctr"/>
-          </a:p>
-        </p:txBody>
-      </p:sp>
-      <p:sp>
-        <p:nvSpPr>
-          <p:cNvPr id="7" name="TextBox 6"/>
+              <a:t>Ce qui ne s'est pas passé du premier coup</a:t>
+            </a:r>
+          </a:p>
+        </p:txBody>
+      </p:sp>
+      <p:sp>
+        <p:nvSpPr>
+          <p:cNvPr id="6" name="TextBox 5"/>
           <p:cNvSpPr txBox="1"/>
           <p:nvPr/>
         </p:nvSpPr>
         <p:spPr>
           <a:xfrm>
-            <a:off x="914400" y="1993392"/>
-            <a:ext cx="10332720" cy="457200"/>
+            <a:off x="640080" y="1691640"/>
+            <a:ext cx="10881360" cy="4480560"/>
           </a:xfrm>
           <a:prstGeom prst="rect">
             <a:avLst/>
@@ -14037,341 +14287,163 @@
           <a:noFill/>
         </p:spPr>
         <p:txBody>
-          <a:bodyPr wrap="square" anchor="ctr" lIns="0" rIns="0" tIns="0" bIns="0">
+          <a:bodyPr wrap="square" lIns="0" rIns="0" tIns="0" bIns="0">
             <a:spAutoFit/>
           </a:bodyPr>
           <a:lstStyle/>
           <a:p>
-            <a:pPr algn="ctr">
-              <a:lnSpc>
-                <a:spcPct val="115000"/>
-              </a:lnSpc>
-            </a:pPr>
-            <a:r>
-              <a:rPr sz="1400" b="1" i="0">
+            <a:pPr algn="l">
+              <a:lnSpc>
+                <a:spcPct val="130000"/>
+              </a:lnSpc>
+              <a:spcAft>
+                <a:spcPts val="900"/>
+              </a:spcAft>
+            </a:pPr>
+            <a:r>
+              <a:rPr sz="1800" b="1">
+                <a:solidFill>
+                  <a:srgbClr val="D97706"/>
+                </a:solidFill>
+                <a:latin typeface="Source Sans 3"/>
+              </a:rPr>
+              <a:t>▸  </a:t>
+            </a:r>
+            <a:r>
+              <a:rPr sz="1800" b="1">
+                <a:solidFill>
+                  <a:srgbClr val="0F172A"/>
+                </a:solidFill>
+                <a:latin typeface="Source Sans 3"/>
+              </a:rPr>
+              <a:t>Concilier le produit existant et le socle attendu — </a:t>
+            </a:r>
+            <a:r>
+              <a:rPr sz="1800">
                 <a:solidFill>
                   <a:srgbClr val="334155"/>
                 </a:solidFill>
                 <a:latin typeface="Source Sans 3"/>
               </a:rPr>
-              <a:t>NAVIGATEUR — frontend HTML / CSS / JS statique</a:t>
-            </a:r>
-          </a:p>
-        </p:txBody>
-      </p:sp>
-      <p:sp>
-        <p:nvSpPr>
-          <p:cNvPr id="8" name="Rounded Rectangle 7"/>
-          <p:cNvSpPr/>
-          <p:nvPr/>
-        </p:nvSpPr>
-        <p:spPr>
-          <a:xfrm>
-            <a:off x="2926080" y="3200400"/>
-            <a:ext cx="2377440" cy="640080"/>
-          </a:xfrm>
-          <a:prstGeom prst="roundRect">
-            <a:avLst>
-              <a:gd name="adj" fmla="val 15000"/>
-            </a:avLst>
-          </a:prstGeom>
-          <a:solidFill>
-            <a:srgbClr val="0F3D91"/>
-          </a:solidFill>
-          <a:ln>
-            <a:noFill/>
-          </a:ln>
-          <a:effectLst/>
-        </p:spPr>
-        <p:style>
-          <a:lnRef idx="1">
-            <a:schemeClr val="accent1"/>
-          </a:lnRef>
-          <a:fillRef idx="3">
-            <a:schemeClr val="accent1"/>
-          </a:fillRef>
-          <a:effectRef idx="2">
-            <a:schemeClr val="accent1"/>
-          </a:effectRef>
-          <a:fontRef idx="minor">
-            <a:schemeClr val="lt1"/>
-          </a:fontRef>
-        </p:style>
-        <p:txBody>
-          <a:bodyPr rtlCol="0" anchor="ctr"/>
-          <a:lstStyle/>
-          <a:p>
-            <a:pPr algn="ctr"/>
-          </a:p>
-        </p:txBody>
-      </p:sp>
-      <p:sp>
-        <p:nvSpPr>
-          <p:cNvPr id="9" name="TextBox 8"/>
-          <p:cNvSpPr txBox="1"/>
-          <p:nvPr/>
-        </p:nvSpPr>
-        <p:spPr>
-          <a:xfrm>
-            <a:off x="2926080" y="3355848"/>
-            <a:ext cx="2377440" cy="365760"/>
-          </a:xfrm>
-          <a:prstGeom prst="rect">
-            <a:avLst/>
-          </a:prstGeom>
-          <a:noFill/>
-        </p:spPr>
-        <p:txBody>
-          <a:bodyPr wrap="square" anchor="t" lIns="0" rIns="0" tIns="0" bIns="0">
-            <a:spAutoFit/>
-          </a:bodyPr>
-          <a:lstStyle/>
-          <a:p>
-            <a:pPr algn="ctr">
-              <a:lnSpc>
-                <a:spcPct val="115000"/>
-              </a:lnSpc>
-            </a:pPr>
-            <a:r>
-              <a:rPr sz="1500" b="1" i="0">
-                <a:solidFill>
-                  <a:srgbClr val="FFFFFF"/>
-                </a:solidFill>
-                <a:latin typeface="Source Sans 3"/>
-              </a:rPr>
-              <a:t>API REST</a:t>
-            </a:r>
-          </a:p>
-        </p:txBody>
-      </p:sp>
-      <p:sp>
-        <p:nvSpPr>
-          <p:cNvPr id="10" name="Rounded Rectangle 9"/>
-          <p:cNvSpPr/>
-          <p:nvPr/>
-        </p:nvSpPr>
-        <p:spPr>
-          <a:xfrm>
-            <a:off x="6903720" y="3200400"/>
-            <a:ext cx="2377440" cy="640080"/>
-          </a:xfrm>
-          <a:prstGeom prst="roundRect">
-            <a:avLst>
-              <a:gd name="adj" fmla="val 15000"/>
-            </a:avLst>
-          </a:prstGeom>
-          <a:solidFill>
-            <a:srgbClr val="0D9488"/>
-          </a:solidFill>
-          <a:ln>
-            <a:noFill/>
-          </a:ln>
-          <a:effectLst/>
-        </p:spPr>
-        <p:style>
-          <a:lnRef idx="1">
-            <a:schemeClr val="accent1"/>
-          </a:lnRef>
-          <a:fillRef idx="3">
-            <a:schemeClr val="accent1"/>
-          </a:fillRef>
-          <a:effectRef idx="2">
-            <a:schemeClr val="accent1"/>
-          </a:effectRef>
-          <a:fontRef idx="minor">
-            <a:schemeClr val="lt1"/>
-          </a:fontRef>
-        </p:style>
-        <p:txBody>
-          <a:bodyPr rtlCol="0" anchor="ctr"/>
-          <a:lstStyle/>
-          <a:p>
-            <a:pPr algn="ctr"/>
-          </a:p>
-        </p:txBody>
-      </p:sp>
-      <p:sp>
-        <p:nvSpPr>
-          <p:cNvPr id="11" name="TextBox 10"/>
-          <p:cNvSpPr txBox="1"/>
-          <p:nvPr/>
-        </p:nvSpPr>
-        <p:spPr>
-          <a:xfrm>
-            <a:off x="6903720" y="3355848"/>
-            <a:ext cx="2377440" cy="365760"/>
-          </a:xfrm>
-          <a:prstGeom prst="rect">
-            <a:avLst/>
-          </a:prstGeom>
-          <a:noFill/>
-        </p:spPr>
-        <p:txBody>
-          <a:bodyPr wrap="square" anchor="t" lIns="0" rIns="0" tIns="0" bIns="0">
-            <a:spAutoFit/>
-          </a:bodyPr>
-          <a:lstStyle/>
-          <a:p>
-            <a:pPr algn="ctr">
-              <a:lnSpc>
-                <a:spcPct val="115000"/>
-              </a:lnSpc>
-            </a:pPr>
-            <a:r>
-              <a:rPr sz="1500" b="1" i="0">
-                <a:solidFill>
-                  <a:srgbClr val="FFFFFF"/>
-                </a:solidFill>
-                <a:latin typeface="Source Sans 3"/>
-              </a:rPr>
-              <a:t>SWAGGER</a:t>
-            </a:r>
-          </a:p>
-        </p:txBody>
-      </p:sp>
-      <p:sp>
-        <p:nvSpPr>
-          <p:cNvPr id="12" name="Rounded Rectangle 11"/>
-          <p:cNvSpPr/>
-          <p:nvPr/>
-        </p:nvSpPr>
-        <p:spPr>
-          <a:xfrm>
-            <a:off x="3246120" y="4343400"/>
-            <a:ext cx="5669280" cy="777240"/>
-          </a:xfrm>
-          <a:prstGeom prst="roundRect">
-            <a:avLst>
-              <a:gd name="adj" fmla="val 12000"/>
-            </a:avLst>
-          </a:prstGeom>
-          <a:solidFill>
-            <a:srgbClr val="0369A1"/>
-          </a:solidFill>
-          <a:ln>
-            <a:noFill/>
-          </a:ln>
-          <a:effectLst/>
-        </p:spPr>
-        <p:style>
-          <a:lnRef idx="1">
-            <a:schemeClr val="accent1"/>
-          </a:lnRef>
-          <a:fillRef idx="3">
-            <a:schemeClr val="accent1"/>
-          </a:fillRef>
-          <a:effectRef idx="2">
-            <a:schemeClr val="accent1"/>
-          </a:effectRef>
-          <a:fontRef idx="minor">
-            <a:schemeClr val="lt1"/>
-          </a:fontRef>
-        </p:style>
-        <p:txBody>
-          <a:bodyPr rtlCol="0" anchor="ctr"/>
-          <a:lstStyle/>
-          <a:p>
-            <a:pPr algn="ctr"/>
-          </a:p>
-        </p:txBody>
-      </p:sp>
-      <p:sp>
-        <p:nvSpPr>
-          <p:cNvPr id="13" name="TextBox 12"/>
-          <p:cNvSpPr txBox="1"/>
-          <p:nvPr/>
-        </p:nvSpPr>
-        <p:spPr>
-          <a:xfrm>
-            <a:off x="3429000" y="4480560"/>
-            <a:ext cx="5303520" cy="548640"/>
-          </a:xfrm>
-          <a:prstGeom prst="rect">
-            <a:avLst/>
-          </a:prstGeom>
-          <a:noFill/>
-        </p:spPr>
-        <p:txBody>
-          <a:bodyPr wrap="square" anchor="t" lIns="0" rIns="0" tIns="0" bIns="0">
-            <a:spAutoFit/>
-          </a:bodyPr>
-          <a:lstStyle/>
-          <a:p>
-            <a:pPr algn="ctr">
-              <a:lnSpc>
-                <a:spcPct val="110000"/>
-              </a:lnSpc>
-            </a:pPr>
-            <a:r>
-              <a:rPr sz="1350" b="1" i="0">
-                <a:solidFill>
-                  <a:srgbClr val="FFFFFF"/>
-                </a:solidFill>
-                <a:latin typeface="Source Sans 3"/>
-              </a:rPr>
-              <a:t>BASE DE DONNÉES POSTGRESQL</a:t>
-            </a:r>
-          </a:p>
-          <a:p>
-            <a:pPr algn="ctr">
-              <a:lnSpc>
-                <a:spcPct val="110000"/>
-              </a:lnSpc>
-            </a:pPr>
-            <a:r>
-              <a:rPr sz="1350" b="1" i="0">
-                <a:solidFill>
-                  <a:srgbClr val="FFFFFF"/>
-                </a:solidFill>
-                <a:latin typeface="Source Sans 3"/>
-              </a:rPr>
-              <a:t>5 tables reliées, via Prisma ORM</a:t>
-            </a:r>
-          </a:p>
-        </p:txBody>
-      </p:sp>
-      <p:sp>
-        <p:nvSpPr>
-          <p:cNvPr id="14" name="TextBox 13"/>
-          <p:cNvSpPr txBox="1"/>
-          <p:nvPr/>
-        </p:nvSpPr>
-        <p:spPr>
-          <a:xfrm>
-            <a:off x="640080" y="5486400"/>
-            <a:ext cx="10881360" cy="731520"/>
-          </a:xfrm>
-          <a:prstGeom prst="rect">
-            <a:avLst/>
-          </a:prstGeom>
-          <a:noFill/>
-        </p:spPr>
-        <p:txBody>
-          <a:bodyPr wrap="square" anchor="t" lIns="0" rIns="0" tIns="0" bIns="0">
-            <a:spAutoFit/>
-          </a:bodyPr>
-          <a:lstStyle/>
-          <a:p>
-            <a:pPr algn="ctr">
-              <a:lnSpc>
-                <a:spcPct val="115000"/>
-              </a:lnSpc>
-            </a:pPr>
-            <a:r>
-              <a:rPr sz="1350" b="0" i="1">
-                <a:solidFill>
-                  <a:srgbClr val="64748B"/>
-                </a:solidFill>
-                <a:latin typeface="Source Sans 3"/>
-              </a:rPr>
-              <a:t>Le frontend appelle l'API en JSON (fetch + jeton JWT). L'API valide les données (Zod) puis lit/écrit dans PostgreSQL via Prisma — jamais d'accès direct du frontend à la base.</a:t>
-            </a:r>
-          </a:p>
-        </p:txBody>
-      </p:sp>
-      <p:sp>
-        <p:nvSpPr>
-          <p:cNvPr id="15" name="Rectangle 14"/>
+              <a:t>réconcilier le référentiel Prepare/Predict déjà conçu avec le socle « Parcoursup classique » exigé par le jury → Prepare/Predict devient une couche de valeur au-dessus d'un vrai socle fonctionnel.</a:t>
+            </a:r>
+          </a:p>
+          <a:p>
+            <a:pPr algn="l">
+              <a:lnSpc>
+                <a:spcPct val="130000"/>
+              </a:lnSpc>
+              <a:spcAft>
+                <a:spcPts val="900"/>
+              </a:spcAft>
+            </a:pPr>
+            <a:r>
+              <a:rPr sz="1800" b="1">
+                <a:solidFill>
+                  <a:srgbClr val="D97706"/>
+                </a:solidFill>
+                <a:latin typeface="Source Sans 3"/>
+              </a:rPr>
+              <a:t>▸  </a:t>
+            </a:r>
+            <a:r>
+              <a:rPr sz="1800" b="1">
+                <a:solidFill>
+                  <a:srgbClr val="0F172A"/>
+                </a:solidFill>
+                <a:latin typeface="Source Sans 3"/>
+              </a:rPr>
+              <a:t>Aucun environnement de test disponible au départ — </a:t>
+            </a:r>
+            <a:r>
+              <a:rPr sz="1800">
+                <a:solidFill>
+                  <a:srgbClr val="334155"/>
+                </a:solidFill>
+                <a:latin typeface="Source Sans 3"/>
+              </a:rPr>
+              <a:t>ni PostgreSQL ni Docker installés → configuration d'un PostgreSQL local pour valider réellement chaque fonctionnalité au fil du développement.</a:t>
+            </a:r>
+          </a:p>
+          <a:p>
+            <a:pPr algn="l">
+              <a:lnSpc>
+                <a:spcPct val="130000"/>
+              </a:lnSpc>
+              <a:spcAft>
+                <a:spcPts val="900"/>
+              </a:spcAft>
+            </a:pPr>
+            <a:r>
+              <a:rPr sz="1800" b="1">
+                <a:solidFill>
+                  <a:srgbClr val="D97706"/>
+                </a:solidFill>
+                <a:latin typeface="Source Sans 3"/>
+              </a:rPr>
+              <a:t>▸  </a:t>
+            </a:r>
+            <a:r>
+              <a:rPr sz="1800" b="1">
+                <a:solidFill>
+                  <a:srgbClr val="0F172A"/>
+                </a:solidFill>
+                <a:latin typeface="Source Sans 3"/>
+              </a:rPr>
+              <a:t>Uniformiser les messages d'erreur — </a:t>
+            </a:r>
+            <a:r>
+              <a:rPr sz="1800">
+                <a:solidFill>
+                  <a:srgbClr val="334155"/>
+                </a:solidFill>
+                <a:latin typeface="Source Sans 3"/>
+              </a:rPr>
+              <a:t>entre la validation de format et les contraintes de la base (email/INE déjà utilisés) → un middleware d'erreur centralisé traduit chaque cas en message clair par champ.</a:t>
+            </a:r>
+          </a:p>
+          <a:p>
+            <a:pPr algn="l">
+              <a:lnSpc>
+                <a:spcPct val="130000"/>
+              </a:lnSpc>
+              <a:spcAft>
+                <a:spcPts val="900"/>
+              </a:spcAft>
+            </a:pPr>
+            <a:r>
+              <a:rPr sz="1800" b="1">
+                <a:solidFill>
+                  <a:srgbClr val="D97706"/>
+                </a:solidFill>
+                <a:latin typeface="Source Sans 3"/>
+              </a:rPr>
+              <a:t>▸  </a:t>
+            </a:r>
+            <a:r>
+              <a:rPr sz="1800" b="1">
+                <a:solidFill>
+                  <a:srgbClr val="0F172A"/>
+                </a:solidFill>
+                <a:latin typeface="Source Sans 3"/>
+              </a:rPr>
+              <a:t>Vérifier le frontend sans navigateur automatisé — </a:t>
+            </a:r>
+            <a:r>
+              <a:rPr sz="1800">
+                <a:solidFill>
+                  <a:srgbClr val="334155"/>
+                </a:solidFill>
+                <a:latin typeface="Source Sans 3"/>
+              </a:rPr>
+              <a:t>environnement sans outil de test headless → scénarios bout-en-bout via l'API en complément des 113 tests automatisés.</a:t>
+            </a:r>
+          </a:p>
+        </p:txBody>
+      </p:sp>
+      <p:sp>
+        <p:nvSpPr>
+          <p:cNvPr id="7" name="Rectangle 6"/>
           <p:cNvSpPr/>
           <p:nvPr/>
         </p:nvSpPr>
@@ -14415,7 +14487,7 @@
       </p:sp>
       <p:sp>
         <p:nvSpPr>
-          <p:cNvPr id="16" name="TextBox 15"/>
+          <p:cNvPr id="8" name="TextBox 7"/>
           <p:cNvSpPr txBox="1"/>
           <p:nvPr/>
         </p:nvSpPr>
@@ -14454,7 +14526,7 @@
       </p:sp>
       <p:sp>
         <p:nvSpPr>
-          <p:cNvPr id="17" name="TextBox 16"/>
+          <p:cNvPr id="9" name="TextBox 8"/>
           <p:cNvSpPr txBox="1"/>
           <p:nvPr/>
         </p:nvSpPr>
@@ -14482,18 +14554,18 @@
             <a:r>
               <a:rPr sz="900" b="1" i="0">
                 <a:solidFill>
-                  <a:srgbClr val="0369A1"/>
-                </a:solidFill>
-                <a:latin typeface="Source Sans 3"/>
-              </a:rPr>
-              <a:t>EXPLICATIONS TECHNIQUES</a:t>
-            </a:r>
-          </a:p>
-        </p:txBody>
-      </p:sp>
-      <p:sp>
-        <p:nvSpPr>
-          <p:cNvPr id="18" name="TextBox 17"/>
+                  <a:srgbClr val="D97706"/>
+                </a:solidFill>
+                <a:latin typeface="Source Sans 3"/>
+              </a:rPr>
+              <a:t>SYNTHÈSE</a:t>
+            </a:r>
+          </a:p>
+        </p:txBody>
+      </p:sp>
+      <p:sp>
+        <p:nvSpPr>
+          <p:cNvPr id="10" name="TextBox 9"/>
           <p:cNvSpPr txBox="1"/>
           <p:nvPr/>
         </p:nvSpPr>
@@ -14525,7 +14597,7 @@
                 </a:solidFill>
                 <a:latin typeface="Source Sans 3"/>
               </a:rPr>
-              <a:t>20</a:t>
+              <a:t>23</a:t>
             </a:r>
           </a:p>
         </p:txBody>
@@ -14607,7 +14679,7 @@
             <a:avLst/>
           </a:prstGeom>
           <a:solidFill>
-            <a:srgbClr val="0369A1"/>
+            <a:srgbClr val="D97706"/>
           </a:solidFill>
           <a:ln>
             <a:noFill/>
@@ -14666,11 +14738,11 @@
             <a:r>
               <a:rPr sz="1300" b="1" i="0">
                 <a:solidFill>
-                  <a:srgbClr val="0369A1"/>
-                </a:solidFill>
-                <a:latin typeface="Source Sans 3"/>
-              </a:rPr>
-              <a:t>EXPLICATIONS TECHNIQUES</a:t>
+                  <a:srgbClr val="D97706"/>
+                </a:solidFill>
+                <a:latin typeface="Source Sans 3"/>
+              </a:rPr>
+              <a:t>AMÉLIORATIONS FUTURES</a:t>
             </a:r>
           </a:p>
         </p:txBody>
@@ -14709,7 +14781,7 @@
                 </a:solidFill>
                 <a:latin typeface="Lexend"/>
               </a:rPr>
-              <a:t>API, base de données, rôles et gestion des erreurs</a:t>
+              <a:t>Les évolutions envisagées pour la suite</a:t>
             </a:r>
           </a:p>
         </p:txBody>
@@ -14747,7 +14819,7 @@
             <a:r>
               <a:rPr sz="1800" b="1">
                 <a:solidFill>
-                  <a:srgbClr val="0369A1"/>
+                  <a:srgbClr val="D97706"/>
                 </a:solidFill>
                 <a:latin typeface="Source Sans 3"/>
               </a:rPr>
@@ -14760,7 +14832,7 @@
                 </a:solidFill>
                 <a:latin typeface="Source Sans 3"/>
               </a:rPr>
-              <a:t>API REST par domaine — </a:t>
+              <a:t>Calcul réel du score de correspondance — </a:t>
             </a:r>
             <a:r>
               <a:rPr sz="1800">
@@ -14769,7 +14841,7 @@
                 </a:solidFill>
                 <a:latin typeface="Source Sans 3"/>
               </a:rPr>
-              <a:t>un module par ressource (écoles, formations, statistiques, vœux, admin), avec routes, contrôleur, service et validation.</a:t>
+              <a:t>aujourd'hui illustratif sur la fiche formation, à remplacer par un algorithme s'appuyant sur le référentiel de compétences.</a:t>
             </a:r>
           </a:p>
           <a:p>
@@ -14784,7 +14856,7 @@
             <a:r>
               <a:rPr sz="1800" b="1">
                 <a:solidFill>
-                  <a:srgbClr val="0369A1"/>
+                  <a:srgbClr val="D97706"/>
                 </a:solidFill>
                 <a:latin typeface="Source Sans 3"/>
               </a:rPr>
@@ -14797,7 +14869,7 @@
                 </a:solidFill>
                 <a:latin typeface="Source Sans 3"/>
               </a:rPr>
-              <a:t>Base de données relationnelle — </a:t>
+              <a:t>Brancher le référentiel Prepare sur l'API — </a:t>
             </a:r>
             <a:r>
               <a:rPr sz="1800">
@@ -14806,7 +14878,7 @@
                 </a:solidFill>
                 <a:latin typeface="Source Sans 3"/>
               </a:rPr>
-              <a:t>écoles → formations → statistiques ; étudiants → vœux → formations, reliées par des clés étrangères.</a:t>
+              <a:t>le constructeur de critères pondérés reste pour l'instant un mockup visuel non connecté à la base de données.</a:t>
             </a:r>
           </a:p>
           <a:p>
@@ -14821,7 +14893,7 @@
             <a:r>
               <a:rPr sz="1800" b="1">
                 <a:solidFill>
-                  <a:srgbClr val="0369A1"/>
+                  <a:srgbClr val="D97706"/>
                 </a:solidFill>
                 <a:latin typeface="Source Sans 3"/>
               </a:rPr>
@@ -14834,7 +14906,7 @@
                 </a:solidFill>
                 <a:latin typeface="Source Sans 3"/>
               </a:rPr>
-              <a:t>Deux rôles applicatifs — </a:t>
+              <a:t>Renforcer la sécurité de l'authentification — </a:t>
             </a:r>
             <a:r>
               <a:rPr sz="1800">
@@ -14843,7 +14915,7 @@
                 </a:solidFill>
                 <a:latin typeface="Source Sans 3"/>
               </a:rPr>
-              <a:t>ÉTUDIANT et ADMINISTRATEUR, vérifiés à chaque requête sensible ; un étudiant n'agit que sur ses propres données.</a:t>
+              <a:t>passer du jeton JWT en localStorage à un cookie httpOnly avec rafraîchissement automatique (refresh token).</a:t>
             </a:r>
           </a:p>
           <a:p>
@@ -14858,7 +14930,7 @@
             <a:r>
               <a:rPr sz="1800" b="1">
                 <a:solidFill>
-                  <a:srgbClr val="0369A1"/>
+                  <a:srgbClr val="D97706"/>
                 </a:solidFill>
                 <a:latin typeface="Source Sans 3"/>
               </a:rPr>
@@ -14871,7 +14943,7 @@
                 </a:solidFill>
                 <a:latin typeface="Source Sans 3"/>
               </a:rPr>
-              <a:t>Erreurs &amp; sécurité — </a:t>
+              <a:t>Intégration continue &amp; tests réels — </a:t>
             </a:r>
             <a:r>
               <a:rPr sz="1800">
@@ -14880,7 +14952,7 @@
                 </a:solidFill>
                 <a:latin typeface="Source Sans 3"/>
               </a:rPr>
-              <a:t>messages clairs par champ, mots de passe hachés, jetons signés, CORS restreint à l'origine du frontend.</a:t>
+              <a:t>exécuter les 113 tests automatiquement à chaque modification, puis tester l'outil avec de vrais élèves et établissements.</a:t>
             </a:r>
           </a:p>
         </p:txBody>
@@ -14998,11 +15070,11 @@
             <a:r>
               <a:rPr sz="900" b="1" i="0">
                 <a:solidFill>
-                  <a:srgbClr val="0369A1"/>
-                </a:solidFill>
-                <a:latin typeface="Source Sans 3"/>
-              </a:rPr>
-              <a:t>EXPLICATIONS TECHNIQUES</a:t>
+                  <a:srgbClr val="D97706"/>
+                </a:solidFill>
+                <a:latin typeface="Source Sans 3"/>
+              </a:rPr>
+              <a:t>SYNTHÈSE</a:t>
             </a:r>
           </a:p>
         </p:txBody>
@@ -15041,7 +15113,7 @@
                 </a:solidFill>
                 <a:latin typeface="Source Sans 3"/>
               </a:rPr>
-              <a:t>21</a:t>
+              <a:t>24</a:t>
             </a:r>
           </a:p>
         </p:txBody>
@@ -15079,7 +15151,7 @@
             <a:avLst/>
           </a:prstGeom>
           <a:solidFill>
-            <a:srgbClr val="F8FAFC"/>
+            <a:srgbClr val="0F3D91"/>
           </a:solidFill>
           <a:ln>
             <a:noFill/>
@@ -15117,13 +15189,13 @@
         <p:spPr>
           <a:xfrm>
             <a:off x="0" y="0"/>
-            <a:ext cx="12191695" cy="109728"/>
+            <a:ext cx="12191695" cy="6858000"/>
           </a:xfrm>
           <a:prstGeom prst="rect">
             <a:avLst/>
           </a:prstGeom>
           <a:solidFill>
-            <a:srgbClr val="D97706"/>
+            <a:srgbClr val="0F3D91"/>
           </a:solidFill>
           <a:ln>
             <a:noFill/>
@@ -15154,14 +15226,58 @@
       </p:sp>
       <p:sp>
         <p:nvSpPr>
-          <p:cNvPr id="4" name="TextBox 3"/>
+          <p:cNvPr id="4" name="Rectangle 3"/>
+          <p:cNvSpPr/>
+          <p:nvPr/>
+        </p:nvSpPr>
+        <p:spPr>
+          <a:xfrm>
+            <a:off x="0" y="0"/>
+            <a:ext cx="12191695" cy="146304"/>
+          </a:xfrm>
+          <a:prstGeom prst="rect">
+            <a:avLst/>
+          </a:prstGeom>
+          <a:solidFill>
+            <a:srgbClr val="F59E0B"/>
+          </a:solidFill>
+          <a:ln>
+            <a:noFill/>
+          </a:ln>
+          <a:effectLst/>
+        </p:spPr>
+        <p:style>
+          <a:lnRef idx="1">
+            <a:schemeClr val="accent1"/>
+          </a:lnRef>
+          <a:fillRef idx="3">
+            <a:schemeClr val="accent1"/>
+          </a:fillRef>
+          <a:effectRef idx="2">
+            <a:schemeClr val="accent1"/>
+          </a:effectRef>
+          <a:fontRef idx="minor">
+            <a:schemeClr val="lt1"/>
+          </a:fontRef>
+        </p:style>
+        <p:txBody>
+          <a:bodyPr rtlCol="0" anchor="ctr"/>
+          <a:lstStyle/>
+          <a:p>
+            <a:pPr algn="ctr"/>
+          </a:p>
+        </p:txBody>
+      </p:sp>
+      <p:sp>
+        <p:nvSpPr>
+          <p:cNvPr id="5" name="TextBox 4"/>
           <p:cNvSpPr txBox="1"/>
           <p:nvPr/>
         </p:nvSpPr>
         <p:spPr>
           <a:xfrm>
-            <a:off x="640080" y="384048"/>
-            <a:ext cx="9144000" cy="320040"/>
+            <a:off x="822960" y="2286000"/>
+            <a:ext cx="10515600" cy="1097280"/>
           </a:xfrm>
           <a:prstGeom prst="rect">
             <a:avLst/>
@@ -15180,27 +15296,27 @@
               </a:lnSpc>
             </a:pPr>
             <a:r>
-              <a:rPr sz="1300" b="1" i="0">
-                <a:solidFill>
-                  <a:srgbClr val="D97706"/>
-                </a:solidFill>
-                <a:latin typeface="Source Sans 3"/>
-              </a:rPr>
-              <a:t>DIFFICULTÉS RENCONTRÉES</a:t>
-            </a:r>
-          </a:p>
-        </p:txBody>
-      </p:sp>
-      <p:sp>
-        <p:nvSpPr>
-          <p:cNvPr id="5" name="TextBox 4"/>
+              <a:rPr sz="6000" b="1" i="0">
+                <a:solidFill>
+                  <a:srgbClr val="FFFFFF"/>
+                </a:solidFill>
+                <a:latin typeface="Lexend"/>
+              </a:rPr>
+              <a:t>Merci.</a:t>
+            </a:r>
+          </a:p>
+        </p:txBody>
+      </p:sp>
+      <p:sp>
+        <p:nvSpPr>
+          <p:cNvPr id="6" name="TextBox 5"/>
           <p:cNvSpPr txBox="1"/>
           <p:nvPr/>
         </p:nvSpPr>
         <p:spPr>
           <a:xfrm>
-            <a:off x="640080" y="685800"/>
-            <a:ext cx="10881360" cy="822960"/>
+            <a:off x="822960" y="3474720"/>
+            <a:ext cx="10058400" cy="914400"/>
           </a:xfrm>
           <a:prstGeom prst="rect">
             <a:avLst/>
@@ -15215,31 +15331,47 @@
           <a:p>
             <a:pPr algn="l">
               <a:lnSpc>
-                <a:spcPct val="105000"/>
-              </a:lnSpc>
-            </a:pPr>
-            <a:r>
-              <a:rPr sz="3000" b="1" i="0">
-                <a:solidFill>
-                  <a:srgbClr val="0F172A"/>
-                </a:solidFill>
-                <a:latin typeface="Lexend"/>
-              </a:rPr>
-              <a:t>Ce qui ne s'est pas passé du premier coup</a:t>
-            </a:r>
-          </a:p>
-        </p:txBody>
-      </p:sp>
-      <p:sp>
-        <p:nvSpPr>
-          <p:cNvPr id="6" name="TextBox 5"/>
+                <a:spcPct val="130000"/>
+              </a:lnSpc>
+            </a:pPr>
+            <a:r>
+              <a:rPr sz="2000" b="0" i="0">
+                <a:solidFill>
+                  <a:srgbClr val="D8F2EE"/>
+                </a:solidFill>
+                <a:latin typeface="Source Sans 3"/>
+              </a:rPr>
+              <a:t>Scoolize aide chaque élève à comprendre ses chances,</a:t>
+            </a:r>
+          </a:p>
+          <a:p>
+            <a:pPr algn="l">
+              <a:lnSpc>
+                <a:spcPct val="130000"/>
+              </a:lnSpc>
+            </a:pPr>
+            <a:r>
+              <a:rPr sz="2000" b="0" i="0">
+                <a:solidFill>
+                  <a:srgbClr val="D8F2EE"/>
+                </a:solidFill>
+                <a:latin typeface="Source Sans 3"/>
+              </a:rPr>
+              <a:t>et chaque établissement à expliquer ses attentes.</a:t>
+            </a:r>
+          </a:p>
+        </p:txBody>
+      </p:sp>
+      <p:sp>
+        <p:nvSpPr>
+          <p:cNvPr id="7" name="TextBox 6"/>
           <p:cNvSpPr txBox="1"/>
           <p:nvPr/>
         </p:nvSpPr>
         <p:spPr>
           <a:xfrm>
-            <a:off x="640080" y="1691640"/>
-            <a:ext cx="10881360" cy="4480560"/>
+            <a:off x="822960" y="6035040"/>
+            <a:ext cx="9144000" cy="365760"/>
           </a:xfrm>
           <a:prstGeom prst="rect">
             <a:avLst/>
@@ -15247,163 +15379,31 @@
           <a:noFill/>
         </p:spPr>
         <p:txBody>
-          <a:bodyPr wrap="square" lIns="0" rIns="0" tIns="0" bIns="0">
+          <a:bodyPr wrap="square" anchor="t" lIns="0" rIns="0" tIns="0" bIns="0">
             <a:spAutoFit/>
           </a:bodyPr>
           <a:lstStyle/>
           <a:p>
             <a:pPr algn="l">
               <a:lnSpc>
-                <a:spcPct val="130000"/>
-              </a:lnSpc>
-              <a:spcAft>
-                <a:spcPts val="900"/>
-              </a:spcAft>
-            </a:pPr>
-            <a:r>
-              <a:rPr sz="1800" b="1">
-                <a:solidFill>
-                  <a:srgbClr val="D97706"/>
-                </a:solidFill>
-                <a:latin typeface="Source Sans 3"/>
-              </a:rPr>
-              <a:t>▸  </a:t>
-            </a:r>
-            <a:r>
-              <a:rPr sz="1800" b="1">
-                <a:solidFill>
-                  <a:srgbClr val="0F172A"/>
-                </a:solidFill>
-                <a:latin typeface="Source Sans 3"/>
-              </a:rPr>
-              <a:t>Concilier le produit existant et le socle attendu — </a:t>
-            </a:r>
-            <a:r>
-              <a:rPr sz="1800">
-                <a:solidFill>
-                  <a:srgbClr val="334155"/>
-                </a:solidFill>
-                <a:latin typeface="Source Sans 3"/>
-              </a:rPr>
-              <a:t>réconcilier le référentiel Prepare/Predict déjà conçu avec le socle « Parcoursup classique » exigé par le jury → Prepare/Predict devient une couche de valeur au-dessus d'un vrai socle fonctionnel.</a:t>
-            </a:r>
-          </a:p>
-          <a:p>
-            <a:pPr algn="l">
-              <a:lnSpc>
-                <a:spcPct val="130000"/>
-              </a:lnSpc>
-              <a:spcAft>
-                <a:spcPts val="900"/>
-              </a:spcAft>
-            </a:pPr>
-            <a:r>
-              <a:rPr sz="1800" b="1">
-                <a:solidFill>
-                  <a:srgbClr val="D97706"/>
-                </a:solidFill>
-                <a:latin typeface="Source Sans 3"/>
-              </a:rPr>
-              <a:t>▸  </a:t>
-            </a:r>
-            <a:r>
-              <a:rPr sz="1800" b="1">
-                <a:solidFill>
-                  <a:srgbClr val="0F172A"/>
-                </a:solidFill>
-                <a:latin typeface="Source Sans 3"/>
-              </a:rPr>
-              <a:t>Aucun environnement de test disponible au départ — </a:t>
-            </a:r>
-            <a:r>
-              <a:rPr sz="1800">
-                <a:solidFill>
-                  <a:srgbClr val="334155"/>
-                </a:solidFill>
-                <a:latin typeface="Source Sans 3"/>
-              </a:rPr>
-              <a:t>ni PostgreSQL ni Docker installés → configuration d'un PostgreSQL local pour valider réellement chaque fonctionnalité au fil du développement.</a:t>
-            </a:r>
-          </a:p>
-          <a:p>
-            <a:pPr algn="l">
-              <a:lnSpc>
-                <a:spcPct val="130000"/>
-              </a:lnSpc>
-              <a:spcAft>
-                <a:spcPts val="900"/>
-              </a:spcAft>
-            </a:pPr>
-            <a:r>
-              <a:rPr sz="1800" b="1">
-                <a:solidFill>
-                  <a:srgbClr val="D97706"/>
-                </a:solidFill>
-                <a:latin typeface="Source Sans 3"/>
-              </a:rPr>
-              <a:t>▸  </a:t>
-            </a:r>
-            <a:r>
-              <a:rPr sz="1800" b="1">
-                <a:solidFill>
-                  <a:srgbClr val="0F172A"/>
-                </a:solidFill>
-                <a:latin typeface="Source Sans 3"/>
-              </a:rPr>
-              <a:t>Uniformiser les messages d'erreur — </a:t>
-            </a:r>
-            <a:r>
-              <a:rPr sz="1800">
-                <a:solidFill>
-                  <a:srgbClr val="334155"/>
-                </a:solidFill>
-                <a:latin typeface="Source Sans 3"/>
-              </a:rPr>
-              <a:t>entre la validation de format et les contraintes de la base (email/INE déjà utilisés) → un middleware d'erreur centralisé traduit chaque cas en message clair par champ.</a:t>
-            </a:r>
-          </a:p>
-          <a:p>
-            <a:pPr algn="l">
-              <a:lnSpc>
-                <a:spcPct val="130000"/>
-              </a:lnSpc>
-              <a:spcAft>
-                <a:spcPts val="900"/>
-              </a:spcAft>
-            </a:pPr>
-            <a:r>
-              <a:rPr sz="1800" b="1">
-                <a:solidFill>
-                  <a:srgbClr val="D97706"/>
-                </a:solidFill>
-                <a:latin typeface="Source Sans 3"/>
-              </a:rPr>
-              <a:t>▸  </a:t>
-            </a:r>
-            <a:r>
-              <a:rPr sz="1800" b="1">
-                <a:solidFill>
-                  <a:srgbClr val="0F172A"/>
-                </a:solidFill>
-                <a:latin typeface="Source Sans 3"/>
-              </a:rPr>
-              <a:t>Vérifier le frontend sans navigateur automatisé — </a:t>
-            </a:r>
-            <a:r>
-              <a:rPr sz="1800">
-                <a:solidFill>
-                  <a:srgbClr val="334155"/>
-                </a:solidFill>
-                <a:latin typeface="Source Sans 3"/>
-              </a:rPr>
-              <a:t>environnement sans outil de test headless → scénarios bout-en-bout via l'API en complément des 97 tests automatisés.</a:t>
-            </a:r>
-          </a:p>
-        </p:txBody>
-      </p:sp>
-      <p:sp>
-        <p:nvSpPr>
-          <p:cNvPr id="7" name="Rectangle 6"/>
+                <a:spcPct val="115000"/>
+              </a:lnSpc>
+            </a:pPr>
+            <a:r>
+              <a:rPr sz="1200" b="0" i="0">
+                <a:solidFill>
+                  <a:srgbClr val="DCE6F7"/>
+                </a:solidFill>
+                <a:latin typeface="Source Sans 3"/>
+              </a:rPr>
+              <a:t>EPI'Gency Digital — Scoolize — Prepare &amp; Predict</a:t>
+            </a:r>
+          </a:p>
+        </p:txBody>
+      </p:sp>
+      <p:sp>
+        <p:nvSpPr>
+          <p:cNvPr id="8" name="Rectangle 7"/>
           <p:cNvSpPr/>
           <p:nvPr/>
         </p:nvSpPr>
@@ -15447,7 +15447,7 @@
       </p:sp>
       <p:sp>
         <p:nvSpPr>
-          <p:cNvPr id="8" name="TextBox 7"/>
+          <p:cNvPr id="9" name="TextBox 8"/>
           <p:cNvSpPr txBox="1"/>
           <p:nvPr/>
         </p:nvSpPr>
@@ -15486,7 +15486,7 @@
       </p:sp>
       <p:sp>
         <p:nvSpPr>
-          <p:cNvPr id="9" name="TextBox 8"/>
+          <p:cNvPr id="10" name="TextBox 9"/>
           <p:cNvSpPr txBox="1"/>
           <p:nvPr/>
         </p:nvSpPr>
@@ -15514,18 +15514,18 @@
             <a:r>
               <a:rPr sz="900" b="1" i="0">
                 <a:solidFill>
-                  <a:srgbClr val="D97706"/>
-                </a:solidFill>
-                <a:latin typeface="Source Sans 3"/>
-              </a:rPr>
-              <a:t>SYNTHÈSE</a:t>
-            </a:r>
-          </a:p>
-        </p:txBody>
-      </p:sp>
-      <p:sp>
-        <p:nvSpPr>
-          <p:cNvPr id="10" name="TextBox 9"/>
+                  <a:srgbClr val="E2E8F0"/>
+                </a:solidFill>
+                <a:latin typeface="Source Sans 3"/>
+              </a:rPr>
+              <a:t>MERCI</a:t>
+            </a:r>
+          </a:p>
+        </p:txBody>
+      </p:sp>
+      <p:sp>
+        <p:nvSpPr>
+          <p:cNvPr id="11" name="TextBox 10"/>
           <p:cNvSpPr txBox="1"/>
           <p:nvPr/>
         </p:nvSpPr>
@@ -15557,7 +15557,7 @@
                 </a:solidFill>
                 <a:latin typeface="Source Sans 3"/>
               </a:rPr>
-              <a:t>23</a:t>
+              <a:t>25</a:t>
             </a:r>
           </a:p>
         </p:txBody>
@@ -18265,7 +18265,7 @@
                 </a:solidFill>
                 <a:latin typeface="Source Sans 3"/>
               </a:rPr>
-              <a:t>une recherche complète, une maquette interactive validée, et désormais une application réelle : API REST, base de données PostgreSQL, comptes utilisateurs, 97 tests automatisés.</a:t>
+              <a:t>une recherche complète, une maquette interactive validée, et désormais une application réelle : API REST, base de données PostgreSQL, comptes utilisateurs, 113 tests automatisés.</a:t>
             </a:r>
           </a:p>
           <a:p>

</xml_diff>

<commit_message>
Reformule la slide 6 : ton confiant, sans reference a une soutenance precedente ni a du travail restant
</commit_message>
<xml_diff>
--- a/08-soutenance/soutenance-scoolize-condensee.pptx
+++ b/08-soutenance/soutenance-scoolize-condensee.pptx
@@ -18205,7 +18205,7 @@
                 </a:solidFill>
                 <a:latin typeface="Lexend"/>
               </a:rPr>
-              <a:t>Une maquette interactive complète, prête à être testée</a:t>
+              <a:t>Une application réelle, de la recherche UX au code qui tourne</a:t>
             </a:r>
           </a:p>
         </p:txBody>
@@ -18256,7 +18256,7 @@
                 </a:solidFill>
                 <a:latin typeface="Source Sans 3"/>
               </a:rPr>
-              <a:t>Ce que nous livrons aujourd'hui — </a:t>
+              <a:t>Ce que nous livrons — </a:t>
             </a:r>
             <a:r>
               <a:rPr sz="1800">
@@ -18265,7 +18265,7 @@
                 </a:solidFill>
                 <a:latin typeface="Source Sans 3"/>
               </a:rPr>
-              <a:t>une recherche complète, une maquette interactive validée, et désormais une application réelle : API REST, base de données PostgreSQL, comptes utilisateurs, 113 tests automatisés.</a:t>
+              <a:t>une recherche UX complète, un prototype interactif soigné, et une application réelle : API REST, base de données PostgreSQL, authentification à trois rôles, 113 tests automatisés.</a:t>
             </a:r>
           </a:p>
           <a:p>
@@ -18293,7 +18293,7 @@
                 </a:solidFill>
                 <a:latin typeface="Source Sans 3"/>
               </a:rPr>
-              <a:t>Ce qui a changé depuis la première soutenance — </a:t>
+              <a:t>Ce qui fonctionne aujourd'hui — </a:t>
             </a:r>
             <a:r>
               <a:rPr sz="1800">
@@ -18302,7 +18302,7 @@
                 </a:solidFill>
                 <a:latin typeface="Source Sans 3"/>
               </a:rPr>
-              <a:t>le backend attendu par le jury est maintenant développé et fonctionnel (détails dans la partie « Explications techniques »).</a:t>
+              <a:t>comptes, recherche de formations, vœux, statistiques et écran d'administration reposent tous sur de vraies données, pas des exemples figés.</a:t>
             </a:r>
           </a:p>
           <a:p>
@@ -18330,7 +18330,7 @@
                 </a:solidFill>
                 <a:latin typeface="Source Sans 3"/>
               </a:rPr>
-              <a:t>Ce qu'il reste à faire — </a:t>
+              <a:t>La suite — </a:t>
             </a:r>
             <a:r>
               <a:rPr sz="1800">
@@ -18339,7 +18339,7 @@
                 </a:solidFill>
                 <a:latin typeface="Source Sans 3"/>
               </a:rPr>
-              <a:t>connecter le calcul du score de correspondance à un vrai algorithme, au-delà de l'exemple illustratif actuel présenté sur la fiche formation.</a:t>
+              <a:t>connecter le référentiel de compétences déjà conçu à un algorithme de score réel, pour aller au bout de la promesse Predict.</a:t>
             </a:r>
           </a:p>
         </p:txBody>

</xml_diff>

<commit_message>
Ajoute un script oral (notes presentateur) pour les 4 slides Explications techniques
</commit_message>
<xml_diff>
--- a/08-soutenance/soutenance-scoolize-condensee.pptx
+++ b/08-soutenance/soutenance-scoolize-condensee.pptx
@@ -1632,6 +1632,364 @@
           <a:p>
             <a:r>
               <a:t>et chaque établissement à expliquer ses attentes. Nous restons à votre disposition pour vos questions.</a:t>
+            </a:r>
+          </a:p>
+        </p:txBody>
+      </p:sp>
+      <p:sp>
+        <p:nvSpPr>
+          <p:cNvPr id="4" name="Slide Number Placeholder 3"/>
+          <p:cNvSpPr>
+            <a:spLocks noGrp="1"/>
+          </p:cNvSpPr>
+          <p:nvPr>
+            <p:ph type="sldNum" idx="5" sz="quarter"/>
+          </p:nvPr>
+        </p:nvSpPr>
+        <p:spPr/>
+      </p:sp>
+    </p:spTree>
+  </p:cSld>
+  <p:clrMapOvr>
+    <a:masterClrMapping/>
+  </p:clrMapOvr>
+</p:notes>
+</file>
+
+<file path=ppt/notesSlides/notesSlide21.xml><?xml version="1.0" encoding="utf-8"?>
+<p:notes xmlns:a="http://schemas.openxmlformats.org/drawingml/2006/main" xmlns:p="http://schemas.openxmlformats.org/presentationml/2006/main" xmlns:r="http://schemas.openxmlformats.org/officeDocument/2006/relationships">
+  <p:cSld>
+    <p:spTree>
+      <p:nvGrpSpPr>
+        <p:cNvPr id="1" name=""/>
+        <p:cNvGrpSpPr/>
+        <p:nvPr/>
+      </p:nvGrpSpPr>
+      <p:grpSpPr>
+        <a:xfrm>
+          <a:off x="0" y="0"/>
+          <a:ext cx="0" cy="0"/>
+          <a:chOff x="0" y="0"/>
+          <a:chExt cx="0" cy="0"/>
+        </a:xfrm>
+      </p:grpSpPr>
+      <p:sp>
+        <p:nvSpPr>
+          <p:cNvPr id="2" name="Slide Image Placeholder 1"/>
+          <p:cNvSpPr>
+            <a:spLocks noGrp="1"/>
+          </p:cNvSpPr>
+          <p:nvPr>
+            <p:ph type="sldImg" idx="2"/>
+          </p:nvPr>
+        </p:nvSpPr>
+        <p:spPr/>
+      </p:sp>
+      <p:sp>
+        <p:nvSpPr>
+          <p:cNvPr id="3" name="Notes Placeholder 2"/>
+          <p:cNvSpPr>
+            <a:spLocks noGrp="1"/>
+          </p:cNvSpPr>
+          <p:nvPr>
+            <p:ph type="body" idx="3" sz="quarter"/>
+          </p:nvPr>
+        </p:nvSpPr>
+        <p:spPr/>
+        <p:txBody>
+          <a:bodyPr/>
+          <a:lstStyle/>
+          <a:p>
+            <a:r>
+              <a:t>Pour la partie backend, on a fait des choix simples mais réfléchis.</a:t>
+            </a:r>
+          </a:p>
+          <a:p/>
+          <a:p>
+            <a:r>
+              <a:t>J'ai utilisé Node.js avec Express pour construire le serveur qui expose notre API. On a choisi Node parce que c'est le même langage que notre frontend — donc toute l'équipe travaille en JavaScript du début à la fin, ça évite de jongler entre plusieurs langages.</a:t>
+            </a:r>
+          </a:p>
+          <a:p/>
+          <a:p>
+            <a:r>
+              <a:t>Pour stocker les données, j'ai utilisé PostgreSQL, une vraie base de données relationnelle, avec Prisma comme ORM par-dessus. Prisma nous sert à décrire nos tables dans un seul fichier, à générer les migrations automatiquement, et à interroger la base sans écrire de SQL à la main — ce qui réduit les risques d'erreur.</a:t>
+            </a:r>
+          </a:p>
+          <a:p/>
+          <a:p>
+            <a:r>
+              <a:t>Pour l'authentification, j'ai utilisé JWT, un jeton signé, combiné à bcrypt pour le hachage des mots de passe. Concrètement : quand quelqu'un se connecte, on vérifie son mot de passe haché, puis on lui donne un jeton qu'il renvoie à chaque requête pour prouver qui il est — jamais son mot de passe en clair.</a:t>
+            </a:r>
+          </a:p>
+          <a:p/>
+          <a:p>
+            <a:r>
+              <a:t>Enfin, pour valider toutes les données qui arrivent — un email, un mot de passe, un numéro INE — j'ai utilisé Zod, qui nous permet de définir des règles claires et de renvoyer un message d'erreur précis si une donnée ne respecte pas le format attendu.</a:t>
+            </a:r>
+          </a:p>
+        </p:txBody>
+      </p:sp>
+      <p:sp>
+        <p:nvSpPr>
+          <p:cNvPr id="4" name="Slide Number Placeholder 3"/>
+          <p:cNvSpPr>
+            <a:spLocks noGrp="1"/>
+          </p:cNvSpPr>
+          <p:nvPr>
+            <p:ph type="sldNum" idx="5" sz="quarter"/>
+          </p:nvPr>
+        </p:nvSpPr>
+        <p:spPr/>
+      </p:sp>
+    </p:spTree>
+  </p:cSld>
+  <p:clrMapOvr>
+    <a:masterClrMapping/>
+  </p:clrMapOvr>
+</p:notes>
+</file>
+
+<file path=ppt/notesSlides/notesSlide22.xml><?xml version="1.0" encoding="utf-8"?>
+<p:notes xmlns:a="http://schemas.openxmlformats.org/drawingml/2006/main" xmlns:p="http://schemas.openxmlformats.org/presentationml/2006/main" xmlns:r="http://schemas.openxmlformats.org/officeDocument/2006/relationships">
+  <p:cSld>
+    <p:spTree>
+      <p:nvGrpSpPr>
+        <p:cNvPr id="1" name=""/>
+        <p:cNvGrpSpPr/>
+        <p:nvPr/>
+      </p:nvGrpSpPr>
+      <p:grpSpPr>
+        <a:xfrm>
+          <a:off x="0" y="0"/>
+          <a:ext cx="0" cy="0"/>
+          <a:chOff x="0" y="0"/>
+          <a:chExt cx="0" cy="0"/>
+        </a:xfrm>
+      </p:grpSpPr>
+      <p:sp>
+        <p:nvSpPr>
+          <p:cNvPr id="2" name="Slide Image Placeholder 1"/>
+          <p:cNvSpPr>
+            <a:spLocks noGrp="1"/>
+          </p:cNvSpPr>
+          <p:nvPr>
+            <p:ph type="sldImg" idx="2"/>
+          </p:nvPr>
+        </p:nvSpPr>
+        <p:spPr/>
+      </p:sp>
+      <p:sp>
+        <p:nvSpPr>
+          <p:cNvPr id="3" name="Notes Placeholder 2"/>
+          <p:cNvSpPr>
+            <a:spLocks noGrp="1"/>
+          </p:cNvSpPr>
+          <p:nvPr>
+            <p:ph type="body" idx="3" sz="quarter"/>
+          </p:nvPr>
+        </p:nvSpPr>
+        <p:spPr/>
+        <p:txBody>
+          <a:bodyPr/>
+          <a:lstStyle/>
+          <a:p>
+            <a:r>
+              <a:t>Côté frontend, j'ai gardé la même approche que pour le prototype déjà validé : du HTML, CSS et JavaScript natif, sans framework comme React ou Vue. On garde ce choix pour rester cohérent avec ce qui avait déjà été conçu, et parce que ça reste simple à comprendre et à faire évoluer pour un projet de cette taille.</a:t>
+            </a:r>
+          </a:p>
+          <a:p/>
+          <a:p>
+            <a:r>
+              <a:t>Pour les tests, j'ai utilisé Jest avec Supertest. Concrètement, ça nous permet d'envoyer de vraies requêtes HTTP à notre API et de vérifier les réponses, contre une vraie base de données de test — pas des simulations. On a 113 tests automatisés qui couvrent l'inscription, la connexion, les écoles, les formations, les statistiques, les vœux et l'administration.</a:t>
+            </a:r>
+          </a:p>
+          <a:p/>
+          <a:p>
+            <a:r>
+              <a:t>Pour documenter l'API, j'ai utilisé Swagger, qui génère une interface interactive à partir de commentaires écrits directement dans le code des routes — n'importe qui peut aller sur l'adresse /api/docs et tester chaque route en direct, sans rien installer.</a:t>
+            </a:r>
+          </a:p>
+          <a:p/>
+          <a:p>
+            <a:r>
+              <a:t>Et pour que tout le monde puisse lancer le projet facilement, j'ai utilisé Docker Compose, qui démarre en une seule commande la base de données, l'API et le frontend ensemble.</a:t>
+            </a:r>
+          </a:p>
+        </p:txBody>
+      </p:sp>
+      <p:sp>
+        <p:nvSpPr>
+          <p:cNvPr id="4" name="Slide Number Placeholder 3"/>
+          <p:cNvSpPr>
+            <a:spLocks noGrp="1"/>
+          </p:cNvSpPr>
+          <p:nvPr>
+            <p:ph type="sldNum" idx="5" sz="quarter"/>
+          </p:nvPr>
+        </p:nvSpPr>
+        <p:spPr/>
+      </p:sp>
+    </p:spTree>
+  </p:cSld>
+  <p:clrMapOvr>
+    <a:masterClrMapping/>
+  </p:clrMapOvr>
+</p:notes>
+</file>
+
+<file path=ppt/notesSlides/notesSlide23.xml><?xml version="1.0" encoding="utf-8"?>
+<p:notes xmlns:a="http://schemas.openxmlformats.org/drawingml/2006/main" xmlns:p="http://schemas.openxmlformats.org/presentationml/2006/main" xmlns:r="http://schemas.openxmlformats.org/officeDocument/2006/relationships">
+  <p:cSld>
+    <p:spTree>
+      <p:nvGrpSpPr>
+        <p:cNvPr id="1" name=""/>
+        <p:cNvGrpSpPr/>
+        <p:nvPr/>
+      </p:nvGrpSpPr>
+      <p:grpSpPr>
+        <a:xfrm>
+          <a:off x="0" y="0"/>
+          <a:ext cx="0" cy="0"/>
+          <a:chOff x="0" y="0"/>
+          <a:chExt cx="0" cy="0"/>
+        </a:xfrm>
+      </p:grpSpPr>
+      <p:sp>
+        <p:nvSpPr>
+          <p:cNvPr id="2" name="Slide Image Placeholder 1"/>
+          <p:cNvSpPr>
+            <a:spLocks noGrp="1"/>
+          </p:cNvSpPr>
+          <p:nvPr>
+            <p:ph type="sldImg" idx="2"/>
+          </p:nvPr>
+        </p:nvSpPr>
+        <p:spPr/>
+      </p:sp>
+      <p:sp>
+        <p:nvSpPr>
+          <p:cNvPr id="3" name="Notes Placeholder 2"/>
+          <p:cNvSpPr>
+            <a:spLocks noGrp="1"/>
+          </p:cNvSpPr>
+          <p:nvPr>
+            <p:ph type="body" idx="3" sz="quarter"/>
+          </p:nvPr>
+        </p:nvSpPr>
+        <p:spPr/>
+        <p:txBody>
+          <a:bodyPr/>
+          <a:lstStyle/>
+          <a:p>
+            <a:r>
+              <a:t>Ce schéma résume comment les trois grandes parties du projet communiquent entre elles.</a:t>
+            </a:r>
+          </a:p>
+          <a:p/>
+          <a:p>
+            <a:r>
+              <a:t>Le navigateur, en haut, c'est notre frontend — des pages HTML classiques. Quand un utilisateur clique quelque part, le frontend envoie une requête à l'API REST, en y ajoutant son jeton de connexion dans l'en-tête.</a:t>
+            </a:r>
+          </a:p>
+          <a:p/>
+          <a:p>
+            <a:r>
+              <a:t>L'API valide les données reçues avec Zod, applique les règles métier — par exemple vérifier qu'un utilisateur a bien le droit de faire cette action — puis va lire ou écrire dans la base de données PostgreSQL, en passant par Prisma.</a:t>
+            </a:r>
+          </a:p>
+          <a:p/>
+          <a:p>
+            <a:r>
+              <a:t>Le point important : le frontend n'a jamais d'accès direct à la base de données. Il passe toujours par l'API, ce qui nous permet de contrôler et de sécuriser chaque accès aux données à un seul endroit.</a:t>
+            </a:r>
+          </a:p>
+        </p:txBody>
+      </p:sp>
+      <p:sp>
+        <p:nvSpPr>
+          <p:cNvPr id="4" name="Slide Number Placeholder 3"/>
+          <p:cNvSpPr>
+            <a:spLocks noGrp="1"/>
+          </p:cNvSpPr>
+          <p:nvPr>
+            <p:ph type="sldNum" idx="5" sz="quarter"/>
+          </p:nvPr>
+        </p:nvSpPr>
+        <p:spPr/>
+      </p:sp>
+    </p:spTree>
+  </p:cSld>
+  <p:clrMapOvr>
+    <a:masterClrMapping/>
+  </p:clrMapOvr>
+</p:notes>
+</file>
+
+<file path=ppt/notesSlides/notesSlide24.xml><?xml version="1.0" encoding="utf-8"?>
+<p:notes xmlns:a="http://schemas.openxmlformats.org/drawingml/2006/main" xmlns:p="http://schemas.openxmlformats.org/presentationml/2006/main" xmlns:r="http://schemas.openxmlformats.org/officeDocument/2006/relationships">
+  <p:cSld>
+    <p:spTree>
+      <p:nvGrpSpPr>
+        <p:cNvPr id="1" name=""/>
+        <p:cNvGrpSpPr/>
+        <p:nvPr/>
+      </p:nvGrpSpPr>
+      <p:grpSpPr>
+        <a:xfrm>
+          <a:off x="0" y="0"/>
+          <a:ext cx="0" cy="0"/>
+          <a:chOff x="0" y="0"/>
+          <a:chExt cx="0" cy="0"/>
+        </a:xfrm>
+      </p:grpSpPr>
+      <p:sp>
+        <p:nvSpPr>
+          <p:cNvPr id="2" name="Slide Image Placeholder 1"/>
+          <p:cNvSpPr>
+            <a:spLocks noGrp="1"/>
+          </p:cNvSpPr>
+          <p:nvPr>
+            <p:ph type="sldImg" idx="2"/>
+          </p:nvPr>
+        </p:nvSpPr>
+        <p:spPr/>
+      </p:sp>
+      <p:sp>
+        <p:nvSpPr>
+          <p:cNvPr id="3" name="Notes Placeholder 2"/>
+          <p:cNvSpPr>
+            <a:spLocks noGrp="1"/>
+          </p:cNvSpPr>
+          <p:nvPr>
+            <p:ph type="body" idx="3" sz="quarter"/>
+          </p:nvPr>
+        </p:nvSpPr>
+        <p:spPr/>
+        <p:txBody>
+          <a:bodyPr/>
+          <a:lstStyle/>
+          <a:p>
+            <a:r>
+              <a:t>Pour organiser le code de l'API, j'ai structuré chaque fonctionnalité en modules indépendants : un module pour les écoles, un pour les formations, un pour les statistiques, un pour les vœux, un pour l'administration. Chaque module a ses propres routes, son contrôleur, son service qui contient la vraie logique métier, et son schéma de validation.</a:t>
+            </a:r>
+          </a:p>
+          <a:p/>
+          <a:p>
+            <a:r>
+              <a:t>Niveau base de données, les tables sont reliées entre elles : une école a plusieurs formations, une formation a plusieurs années de statistiques, et un étudiant peut faire plusieurs vœux, chacun ciblant une formation précise.</a:t>
+            </a:r>
+          </a:p>
+          <a:p/>
+          <a:p>
+            <a:r>
+              <a:t>J'ai mis en place trois rôles réels : étudiant, personnel d'établissement, et administrateur. Et ce n'est pas juste une étiquette sur le compte — c'est vérifié à chaque requête, coté serveur. Par exemple, si Camille, qui gère l'IUT de Bordeaux, essaie de modifier une formation d'une autre école, le serveur lui refuse explicitement l'accès.</a:t>
+            </a:r>
+          </a:p>
+          <a:p/>
+          <a:p>
+            <a:r>
+              <a:t>Enfin, pour la gestion des erreurs, j'ai centralisé tout ça dans un seul middleware qui transforme n'importe quelle erreur — un champ invalide, un email déjà utilisé, une ressource introuvable — en un message clair et compréhensible, affiché directement dans le formulaire concerné.</a:t>
             </a:r>
           </a:p>
         </p:txBody>

</xml_diff>